<commit_message>
Replace hand-drawn friends with Fluent Emoji 3D animals and birds (MIT) in fathah, kasrah and dammah decks
Shared animals/ folder: 30 land animals, sea animals for sea scenes, flying friends; each faces the middle of the slide.

Co-Authored-By: Claude Opus 5.5 <noreply@anthropic.com>
Claude-Session: https://claude.ai/code/session_01XjTEwQ8YdBa1SjcPiYTm9z
</commit_message>
<xml_diff>
--- a/dammah-plus/01-alif.pptx
+++ b/dammah-plus/01-alif.pptx
@@ -3430,7 +3430,7 @@
       </p:sp>
       <p:pic>
         <p:nvPicPr>
-          <p:cNvPr id="14" name="Image 0" descr="duck">    </p:cNvPr>
+          <p:cNvPr id="14" name="Image 0" descr="giraffe">    </p:cNvPr>
           <p:cNvPicPr>
             <a:picLocks noChangeAspect="1"/>
           </p:cNvPicPr>
@@ -3443,9 +3443,9 @@
           </a:stretch>
         </p:blipFill>
         <p:spPr>
-          <a:xfrm>
-            <a:off x="91440" y="1783080"/>
-            <a:ext cx="1313536" cy="1554480"/>
+          <a:xfrm flipH="1">
+            <a:off x="91440" y="1828800"/>
+            <a:ext cx="1372332" cy="1463040"/>
           </a:xfrm>
           <a:prstGeom prst="rect">
             <a:avLst/>
@@ -3454,7 +3454,7 @@
       </p:pic>
       <p:pic>
         <p:nvPicPr>
-          <p:cNvPr id="15" name="Image 1" descr="rabbit">    </p:cNvPr>
+          <p:cNvPr id="15" name="Image 1" descr="owl">    </p:cNvPr>
           <p:cNvPicPr>
             <a:picLocks noChangeAspect="1"/>
           </p:cNvPicPr>
@@ -3468,8 +3468,8 @@
         </p:blipFill>
         <p:spPr>
           <a:xfrm>
-            <a:off x="7841620" y="1783080"/>
-            <a:ext cx="1210940" cy="1554480"/>
+            <a:off x="7902611" y="1828800"/>
+            <a:ext cx="1149949" cy="1463040"/>
           </a:xfrm>
           <a:prstGeom prst="rect">
             <a:avLst/>
@@ -3478,7 +3478,7 @@
       </p:pic>
       <p:pic>
         <p:nvPicPr>
-          <p:cNvPr id="16" name="Image 2" descr="bird1">    </p:cNvPr>
+          <p:cNvPr id="16" name="Image 2" descr="honeybee">    </p:cNvPr>
           <p:cNvPicPr>
             <a:picLocks noChangeAspect="1"/>
           </p:cNvPicPr>
@@ -3492,8 +3492,8 @@
         </p:blipFill>
         <p:spPr>
           <a:xfrm flipH="1">
-            <a:off x="5302057" y="45720"/>
-            <a:ext cx="1007303" cy="777240"/>
+            <a:off x="1920240" y="45720"/>
+            <a:ext cx="825429" cy="777240"/>
           </a:xfrm>
           <a:prstGeom prst="rect">
             <a:avLst/>
@@ -4527,7 +4527,7 @@
       </p:sp>
       <p:pic>
         <p:nvPicPr>
-          <p:cNvPr id="32" name="Image 0" descr="butterfly1">    </p:cNvPr>
+          <p:cNvPr id="32" name="Image 0" descr="dove">    </p:cNvPr>
           <p:cNvPicPr>
             <a:picLocks noChangeAspect="1"/>
           </p:cNvPicPr>
@@ -4541,8 +4541,8 @@
         </p:blipFill>
         <p:spPr>
           <a:xfrm>
-            <a:off x="1005840" y="45720"/>
-            <a:ext cx="906262" cy="777240"/>
+            <a:off x="4803709" y="45720"/>
+            <a:ext cx="774131" cy="777240"/>
           </a:xfrm>
           <a:prstGeom prst="rect">
             <a:avLst/>
@@ -5940,7 +5940,7 @@
       </p:sp>
       <p:pic>
         <p:nvPicPr>
-          <p:cNvPr id="29" name="Image 0" descr="cat">    </p:cNvPr>
+          <p:cNvPr id="29" name="Image 0" descr="parrot">    </p:cNvPr>
           <p:cNvPicPr>
             <a:picLocks noChangeAspect="1"/>
           </p:cNvPicPr>
@@ -5953,9 +5953,9 @@
           </a:stretch>
         </p:blipFill>
         <p:spPr>
-          <a:xfrm>
-            <a:off x="91440" y="4023360"/>
-            <a:ext cx="894878" cy="1051560"/>
+          <a:xfrm flipH="1">
+            <a:off x="91440" y="4018788"/>
+            <a:ext cx="906445" cy="1051560"/>
           </a:xfrm>
           <a:prstGeom prst="rect">
             <a:avLst/>
@@ -5964,7 +5964,7 @@
       </p:pic>
       <p:pic>
         <p:nvPicPr>
-          <p:cNvPr id="30" name="Image 1" descr="rabbit">    </p:cNvPr>
+          <p:cNvPr id="30" name="Image 1" descr="honeybee">    </p:cNvPr>
           <p:cNvPicPr>
             <a:picLocks noChangeAspect="1"/>
           </p:cNvPicPr>
@@ -5977,33 +5977,9 @@
           </a:stretch>
         </p:blipFill>
         <p:spPr>
-          <a:xfrm>
-            <a:off x="8498799" y="4343400"/>
-            <a:ext cx="553761" cy="731520"/>
-          </a:xfrm>
-          <a:prstGeom prst="rect">
-            <a:avLst/>
-          </a:prstGeom>
-        </p:spPr>
-      </p:pic>
-      <p:pic>
-        <p:nvPicPr>
-          <p:cNvPr id="31" name="Image 2" descr="bird1">    </p:cNvPr>
-          <p:cNvPicPr>
-            <a:picLocks noChangeAspect="1"/>
-          </p:cNvPicPr>
-          <p:nvPr/>
-        </p:nvPicPr>
-        <p:blipFill>
-          <a:blip r:embed="rId3"/>
-          <a:stretch>
-            <a:fillRect/>
-          </a:stretch>
-        </p:blipFill>
-        <p:spPr>
           <a:xfrm flipH="1">
-            <a:off x="5479816" y="45720"/>
-            <a:ext cx="829544" cy="640080"/>
+            <a:off x="2834640" y="45720"/>
+            <a:ext cx="825429" cy="777240"/>
           </a:xfrm>
           <a:prstGeom prst="rect">
             <a:avLst/>
@@ -7274,7 +7250,7 @@
       </p:sp>
       <p:pic>
         <p:nvPicPr>
-          <p:cNvPr id="24" name="Image 0" descr="bird">    </p:cNvPr>
+          <p:cNvPr id="24" name="Image 0" descr="turtle">    </p:cNvPr>
           <p:cNvPicPr>
             <a:picLocks noChangeAspect="1"/>
           </p:cNvPicPr>
@@ -7287,9 +7263,9 @@
           </a:stretch>
         </p:blipFill>
         <p:spPr>
-          <a:xfrm>
-            <a:off x="91440" y="3566160"/>
-            <a:ext cx="1338270" cy="1508760"/>
+          <a:xfrm flipH="1">
+            <a:off x="91440" y="3561588"/>
+            <a:ext cx="2432121" cy="1508760"/>
           </a:xfrm>
           <a:prstGeom prst="rect">
             <a:avLst/>
@@ -7298,7 +7274,7 @@
       </p:pic>
       <p:pic>
         <p:nvPicPr>
-          <p:cNvPr id="25" name="Image 1" descr="rabbit">    </p:cNvPr>
+          <p:cNvPr id="25" name="Image 1" descr="monkey">    </p:cNvPr>
           <p:cNvPicPr>
             <a:picLocks noChangeAspect="1"/>
           </p:cNvPicPr>
@@ -7312,8 +7288,8 @@
         </p:blipFill>
         <p:spPr>
           <a:xfrm>
-            <a:off x="7848570" y="3337560"/>
-            <a:ext cx="1203990" cy="1737360"/>
+            <a:off x="7075444" y="3332988"/>
+            <a:ext cx="1977116" cy="1737360"/>
           </a:xfrm>
           <a:prstGeom prst="rect">
             <a:avLst/>
@@ -7322,7 +7298,7 @@
       </p:pic>
       <p:pic>
         <p:nvPicPr>
-          <p:cNvPr id="26" name="Image 2" descr="bird4">    </p:cNvPr>
+          <p:cNvPr id="26" name="Image 2" descr="lady_beetle">    </p:cNvPr>
           <p:cNvPicPr>
             <a:picLocks noChangeAspect="1"/>
           </p:cNvPicPr>
@@ -7336,8 +7312,8 @@
         </p:blipFill>
         <p:spPr>
           <a:xfrm>
-            <a:off x="1920240" y="45720"/>
-            <a:ext cx="888797" cy="685800"/>
+            <a:off x="5758525" y="45720"/>
+            <a:ext cx="550835" cy="548640"/>
           </a:xfrm>
           <a:prstGeom prst="rect">
             <a:avLst/>
@@ -8633,7 +8609,7 @@
       </p:sp>
       <p:pic>
         <p:nvPicPr>
-          <p:cNvPr id="25" name="Image 0" descr="turtle">    </p:cNvPr>
+          <p:cNvPr id="25" name="Image 0" descr="deer">    </p:cNvPr>
           <p:cNvPicPr>
             <a:picLocks noChangeAspect="1"/>
           </p:cNvPicPr>
@@ -8646,9 +8622,9 @@
           </a:stretch>
         </p:blipFill>
         <p:spPr>
-          <a:xfrm>
-            <a:off x="91440" y="4023360"/>
-            <a:ext cx="1077849" cy="1051560"/>
+          <a:xfrm flipH="1">
+            <a:off x="91440" y="3973068"/>
+            <a:ext cx="1097280" cy="1097280"/>
           </a:xfrm>
           <a:prstGeom prst="rect">
             <a:avLst/>
@@ -8657,7 +8633,7 @@
       </p:pic>
       <p:pic>
         <p:nvPicPr>
-          <p:cNvPr id="26" name="Image 1" descr="dog">    </p:cNvPr>
+          <p:cNvPr id="26" name="Image 1" descr="bird">    </p:cNvPr>
           <p:cNvPicPr>
             <a:picLocks noChangeAspect="1"/>
           </p:cNvPicPr>
@@ -8670,33 +8646,9 @@
           </a:stretch>
         </p:blipFill>
         <p:spPr>
-          <a:xfrm>
-            <a:off x="8321772" y="4251960"/>
-            <a:ext cx="730788" cy="822960"/>
-          </a:xfrm>
-          <a:prstGeom prst="rect">
-            <a:avLst/>
-          </a:prstGeom>
-        </p:spPr>
-      </p:pic>
-      <p:pic>
-        <p:nvPicPr>
-          <p:cNvPr id="27" name="Image 2" descr="bee">    </p:cNvPr>
-          <p:cNvPicPr>
-            <a:picLocks noChangeAspect="1"/>
-          </p:cNvPicPr>
-          <p:nvPr/>
-        </p:nvPicPr>
-        <p:blipFill>
-          <a:blip r:embed="rId3"/>
-          <a:stretch>
-            <a:fillRect/>
-          </a:stretch>
-        </p:blipFill>
-        <p:spPr>
-          <a:xfrm>
-            <a:off x="5507248" y="45720"/>
-            <a:ext cx="802112" cy="777240"/>
+          <a:xfrm flipH="1">
+            <a:off x="1920240" y="45720"/>
+            <a:ext cx="742264" cy="777240"/>
           </a:xfrm>
           <a:prstGeom prst="rect">
             <a:avLst/>
@@ -10017,7 +9969,7 @@
       </p:sp>
       <p:pic>
         <p:nvPicPr>
-          <p:cNvPr id="26" name="Image 0" descr="rabbit">    </p:cNvPr>
+          <p:cNvPr id="26" name="Image 0" descr="goat">    </p:cNvPr>
           <p:cNvPicPr>
             <a:picLocks noChangeAspect="1"/>
           </p:cNvPicPr>
@@ -10031,8 +9983,8 @@
         </p:blipFill>
         <p:spPr>
           <a:xfrm>
-            <a:off x="91440" y="3566160"/>
-            <a:ext cx="1128552" cy="1508760"/>
+            <a:off x="91440" y="3561588"/>
+            <a:ext cx="1615882" cy="1508760"/>
           </a:xfrm>
           <a:prstGeom prst="rect">
             <a:avLst/>
@@ -10041,7 +9993,7 @@
       </p:pic>
       <p:pic>
         <p:nvPicPr>
-          <p:cNvPr id="27" name="Image 1" descr="dog">    </p:cNvPr>
+          <p:cNvPr id="27" name="Image 1" descr="swan">    </p:cNvPr>
           <p:cNvPicPr>
             <a:picLocks noChangeAspect="1"/>
           </p:cNvPicPr>
@@ -10055,8 +10007,32 @@
         </p:blipFill>
         <p:spPr>
           <a:xfrm>
-            <a:off x="7428128" y="3337560"/>
-            <a:ext cx="1624432" cy="1737360"/>
+            <a:off x="7181423" y="3332988"/>
+            <a:ext cx="1871137" cy="1737360"/>
+          </a:xfrm>
+          <a:prstGeom prst="rect">
+            <a:avLst/>
+          </a:prstGeom>
+        </p:spPr>
+      </p:pic>
+      <p:pic>
+        <p:nvPicPr>
+          <p:cNvPr id="28" name="Image 2" descr="butterfly">    </p:cNvPr>
+          <p:cNvPicPr>
+            <a:picLocks noChangeAspect="1"/>
+          </p:cNvPicPr>
+          <p:nvPr/>
+        </p:nvPicPr>
+        <p:blipFill>
+          <a:blip r:embed="rId3"/>
+          <a:stretch>
+            <a:fillRect/>
+          </a:stretch>
+        </p:blipFill>
+        <p:spPr>
+          <a:xfrm>
+            <a:off x="4800600" y="45720"/>
+            <a:ext cx="777240" cy="777240"/>
           </a:xfrm>
           <a:prstGeom prst="rect">
             <a:avLst/>
@@ -11337,7 +11313,7 @@
       </p:sp>
       <p:pic>
         <p:nvPicPr>
-          <p:cNvPr id="24" name="Image 0" descr="fish">    </p:cNvPr>
+          <p:cNvPr id="24" name="Image 0" descr="swan">    </p:cNvPr>
           <p:cNvPicPr>
             <a:picLocks noChangeAspect="1"/>
           </p:cNvPicPr>
@@ -11350,9 +11326,9 @@
           </a:stretch>
         </p:blipFill>
         <p:spPr>
-          <a:xfrm>
-            <a:off x="91440" y="3566160"/>
-            <a:ext cx="1875389" cy="1508760"/>
+          <a:xfrm flipH="1">
+            <a:off x="91440" y="3561588"/>
+            <a:ext cx="1624935" cy="1508760"/>
           </a:xfrm>
           <a:prstGeom prst="rect">
             <a:avLst/>
@@ -11361,7 +11337,7 @@
       </p:pic>
       <p:pic>
         <p:nvPicPr>
-          <p:cNvPr id="25" name="Image 1" descr="dog">    </p:cNvPr>
+          <p:cNvPr id="25" name="Image 1" descr="turtle">    </p:cNvPr>
           <p:cNvPicPr>
             <a:picLocks noChangeAspect="1"/>
           </p:cNvPicPr>
@@ -11375,8 +11351,8 @@
         </p:blipFill>
         <p:spPr>
           <a:xfrm>
-            <a:off x="7490673" y="3337560"/>
-            <a:ext cx="1561887" cy="1737360"/>
+            <a:off x="6251936" y="3332988"/>
+            <a:ext cx="2800624" cy="1737360"/>
           </a:xfrm>
           <a:prstGeom prst="rect">
             <a:avLst/>
@@ -11385,7 +11361,7 @@
       </p:pic>
       <p:pic>
         <p:nvPicPr>
-          <p:cNvPr id="26" name="Image 2" descr="butterfly1">    </p:cNvPr>
+          <p:cNvPr id="26" name="Image 2" descr="dove">    </p:cNvPr>
           <p:cNvPicPr>
             <a:picLocks noChangeAspect="1"/>
           </p:cNvPicPr>
@@ -11398,9 +11374,9 @@
           </a:stretch>
         </p:blipFill>
         <p:spPr>
-          <a:xfrm>
-            <a:off x="6317498" y="45720"/>
-            <a:ext cx="906262" cy="777240"/>
+          <a:xfrm flipH="1">
+            <a:off x="1920240" y="45720"/>
+            <a:ext cx="774131" cy="777240"/>
           </a:xfrm>
           <a:prstGeom prst="rect">
             <a:avLst/>
@@ -12743,7 +12719,7 @@
       </p:sp>
       <p:pic>
         <p:nvPicPr>
-          <p:cNvPr id="28" name="Image 0" descr="bird1">    </p:cNvPr>
+          <p:cNvPr id="28" name="Image 0" descr="honeybee">    </p:cNvPr>
           <p:cNvPicPr>
             <a:picLocks noChangeAspect="1"/>
           </p:cNvPicPr>
@@ -12757,8 +12733,8 @@
         </p:blipFill>
         <p:spPr>
           <a:xfrm>
-            <a:off x="1005840" y="45720"/>
-            <a:ext cx="1007303" cy="777240"/>
+            <a:off x="4752411" y="45720"/>
+            <a:ext cx="825429" cy="777240"/>
           </a:xfrm>
           <a:prstGeom prst="rect">
             <a:avLst/>
@@ -13866,7 +13842,7 @@
       </p:sp>
       <p:pic>
         <p:nvPicPr>
-          <p:cNvPr id="25" name="Image 0" descr="duck">    </p:cNvPr>
+          <p:cNvPr id="25" name="Image 0" descr="chipmunk">    </p:cNvPr>
           <p:cNvPicPr>
             <a:picLocks noChangeAspect="1"/>
           </p:cNvPicPr>
@@ -13879,9 +13855,9 @@
           </a:stretch>
         </p:blipFill>
         <p:spPr>
-          <a:xfrm>
-            <a:off x="91440" y="3977640"/>
-            <a:ext cx="927202" cy="1097280"/>
+          <a:xfrm flipH="1">
+            <a:off x="91440" y="4201668"/>
+            <a:ext cx="900821" cy="868680"/>
           </a:xfrm>
           <a:prstGeom prst="rect">
             <a:avLst/>
@@ -13890,7 +13866,7 @@
       </p:pic>
       <p:pic>
         <p:nvPicPr>
-          <p:cNvPr id="26" name="Image 1" descr="rabbit">    </p:cNvPr>
+          <p:cNvPr id="26" name="Image 1" descr="lady_beetle">    </p:cNvPr>
           <p:cNvPicPr>
             <a:picLocks noChangeAspect="1"/>
           </p:cNvPicPr>
@@ -13904,32 +13880,8 @@
         </p:blipFill>
         <p:spPr>
           <a:xfrm>
-            <a:off x="8482706" y="4343400"/>
-            <a:ext cx="569854" cy="731520"/>
-          </a:xfrm>
-          <a:prstGeom prst="rect">
-            <a:avLst/>
-          </a:prstGeom>
-        </p:spPr>
-      </p:pic>
-      <p:pic>
-        <p:nvPicPr>
-          <p:cNvPr id="27" name="Image 2" descr="bird4">    </p:cNvPr>
-          <p:cNvPicPr>
-            <a:picLocks noChangeAspect="1"/>
-          </p:cNvPicPr>
-          <p:nvPr/>
-        </p:nvPicPr>
-        <p:blipFill>
-          <a:blip r:embed="rId3"/>
-          <a:stretch>
-            <a:fillRect/>
-          </a:stretch>
-        </p:blipFill>
-        <p:spPr>
-          <a:xfrm flipH="1">
-            <a:off x="5479816" y="45720"/>
-            <a:ext cx="829544" cy="640080"/>
+            <a:off x="2834640" y="45720"/>
+            <a:ext cx="780349" cy="777240"/>
           </a:xfrm>
           <a:prstGeom prst="rect">
             <a:avLst/>
@@ -14910,7 +14862,7 @@
       </p:sp>
       <p:pic>
         <p:nvPicPr>
-          <p:cNvPr id="20" name="Image 0" descr="dog">    </p:cNvPr>
+          <p:cNvPr id="20" name="Image 0" descr="flamingo">    </p:cNvPr>
           <p:cNvPicPr>
             <a:picLocks noChangeAspect="1"/>
           </p:cNvPicPr>
@@ -14923,9 +14875,9 @@
           </a:stretch>
         </p:blipFill>
         <p:spPr>
-          <a:xfrm>
-            <a:off x="91440" y="3657600"/>
-            <a:ext cx="1339367" cy="1417320"/>
+          <a:xfrm flipH="1">
+            <a:off x="91440" y="3653028"/>
+            <a:ext cx="1106927" cy="1417320"/>
           </a:xfrm>
           <a:prstGeom prst="rect">
             <a:avLst/>
@@ -14934,7 +14886,7 @@
       </p:pic>
       <p:pic>
         <p:nvPicPr>
-          <p:cNvPr id="21" name="Image 1" descr="rabbit">    </p:cNvPr>
+          <p:cNvPr id="21" name="Image 1" descr="hatching_chick">    </p:cNvPr>
           <p:cNvPicPr>
             <a:picLocks noChangeAspect="1"/>
           </p:cNvPicPr>
@@ -14948,8 +14900,8 @@
         </p:blipFill>
         <p:spPr>
           <a:xfrm>
-            <a:off x="7894472" y="3520440"/>
-            <a:ext cx="1158088" cy="1554480"/>
+            <a:off x="7498080" y="3515868"/>
+            <a:ext cx="1554480" cy="1554480"/>
           </a:xfrm>
           <a:prstGeom prst="rect">
             <a:avLst/>
@@ -14958,7 +14910,7 @@
       </p:pic>
       <p:pic>
         <p:nvPicPr>
-          <p:cNvPr id="22" name="Image 2" descr="bee">    </p:cNvPr>
+          <p:cNvPr id="22" name="Image 2" descr="bird">    </p:cNvPr>
           <p:cNvPicPr>
             <a:picLocks noChangeAspect="1"/>
           </p:cNvPicPr>
@@ -14972,8 +14924,8 @@
         </p:blipFill>
         <p:spPr>
           <a:xfrm>
-            <a:off x="1920240" y="45720"/>
-            <a:ext cx="802112" cy="777240"/>
+            <a:off x="5785409" y="45720"/>
+            <a:ext cx="523951" cy="548640"/>
           </a:xfrm>
           <a:prstGeom prst="rect">
             <a:avLst/>
@@ -15979,7 +15931,7 @@
       </p:sp>
       <p:pic>
         <p:nvPicPr>
-          <p:cNvPr id="21" name="Image 0" descr="cat">    </p:cNvPr>
+          <p:cNvPr id="21" name="Image 0" descr="kangaroo">    </p:cNvPr>
           <p:cNvPicPr>
             <a:picLocks noChangeAspect="1"/>
           </p:cNvPicPr>
@@ -15993,8 +15945,8 @@
         </p:blipFill>
         <p:spPr>
           <a:xfrm>
-            <a:off x="91440" y="3794760"/>
-            <a:ext cx="1089416" cy="1280160"/>
+            <a:off x="91440" y="4064508"/>
+            <a:ext cx="1078260" cy="1005840"/>
           </a:xfrm>
           <a:prstGeom prst="rect">
             <a:avLst/>
@@ -16003,7 +15955,7 @@
       </p:pic>
       <p:pic>
         <p:nvPicPr>
-          <p:cNvPr id="22" name="Image 1" descr="rabbit">    </p:cNvPr>
+          <p:cNvPr id="22" name="Image 1" descr="cat">    </p:cNvPr>
           <p:cNvPicPr>
             <a:picLocks noChangeAspect="1"/>
           </p:cNvPicPr>
@@ -16017,8 +15969,8 @@
         </p:blipFill>
         <p:spPr>
           <a:xfrm>
-            <a:off x="8325749" y="4114800"/>
-            <a:ext cx="726811" cy="960120"/>
+            <a:off x="8341385" y="4384548"/>
+            <a:ext cx="711175" cy="685800"/>
           </a:xfrm>
           <a:prstGeom prst="rect">
             <a:avLst/>
@@ -16027,7 +15979,7 @@
       </p:pic>
       <p:pic>
         <p:nvPicPr>
-          <p:cNvPr id="23" name="Image 2" descr="bird2">    </p:cNvPr>
+          <p:cNvPr id="23" name="Image 2" descr="butterfly">    </p:cNvPr>
           <p:cNvPicPr>
             <a:picLocks noChangeAspect="1"/>
           </p:cNvPicPr>
@@ -16040,9 +15992,9 @@
           </a:stretch>
         </p:blipFill>
         <p:spPr>
-          <a:xfrm flipH="1">
-            <a:off x="5333147" y="45720"/>
-            <a:ext cx="976213" cy="777240"/>
+          <a:xfrm>
+            <a:off x="1920240" y="45720"/>
+            <a:ext cx="777240" cy="777240"/>
           </a:xfrm>
           <a:prstGeom prst="rect">
             <a:avLst/>
@@ -17073,7 +17025,7 @@
       </p:sp>
       <p:pic>
         <p:nvPicPr>
-          <p:cNvPr id="22" name="Image 0" descr="dog">    </p:cNvPr>
+          <p:cNvPr id="22" name="Image 0" descr="llama">    </p:cNvPr>
           <p:cNvPicPr>
             <a:picLocks noChangeAspect="1"/>
           </p:cNvPicPr>
@@ -17086,9 +17038,9 @@
           </a:stretch>
         </p:blipFill>
         <p:spPr>
-          <a:xfrm>
-            <a:off x="91440" y="3657600"/>
-            <a:ext cx="1339367" cy="1417320"/>
+          <a:xfrm flipH="1">
+            <a:off x="91440" y="3653028"/>
+            <a:ext cx="1322360" cy="1417320"/>
           </a:xfrm>
           <a:prstGeom prst="rect">
             <a:avLst/>
@@ -17097,7 +17049,7 @@
       </p:pic>
       <p:pic>
         <p:nvPicPr>
-          <p:cNvPr id="23" name="Image 1" descr="rabbit">    </p:cNvPr>
+          <p:cNvPr id="23" name="Image 1" descr="ewe">    </p:cNvPr>
           <p:cNvPicPr>
             <a:picLocks noChangeAspect="1"/>
           </p:cNvPicPr>
@@ -17111,8 +17063,32 @@
         </p:blipFill>
         <p:spPr>
           <a:xfrm>
-            <a:off x="7894472" y="3520440"/>
-            <a:ext cx="1158088" cy="1554480"/>
+            <a:off x="7498080" y="3515868"/>
+            <a:ext cx="1554480" cy="1554480"/>
+          </a:xfrm>
+          <a:prstGeom prst="rect">
+            <a:avLst/>
+          </a:prstGeom>
+        </p:spPr>
+      </p:pic>
+      <p:pic>
+        <p:nvPicPr>
+          <p:cNvPr id="24" name="Image 2" descr="lady_beetle">    </p:cNvPr>
+          <p:cNvPicPr>
+            <a:picLocks noChangeAspect="1"/>
+          </p:cNvPicPr>
+          <p:nvPr/>
+        </p:nvPicPr>
+        <p:blipFill>
+          <a:blip r:embed="rId3"/>
+          <a:stretch>
+            <a:fillRect/>
+          </a:stretch>
+        </p:blipFill>
+        <p:spPr>
+          <a:xfrm>
+            <a:off x="4797491" y="45720"/>
+            <a:ext cx="780349" cy="777240"/>
           </a:xfrm>
           <a:prstGeom prst="rect">
             <a:avLst/>
@@ -18143,7 +18119,7 @@
       </p:sp>
       <p:pic>
         <p:nvPicPr>
-          <p:cNvPr id="22" name="Image 0" descr="bird">    </p:cNvPr>
+          <p:cNvPr id="22" name="Image 0" descr="rabbit">    </p:cNvPr>
           <p:cNvPicPr>
             <a:picLocks noChangeAspect="1"/>
           </p:cNvPicPr>
@@ -18156,9 +18132,9 @@
           </a:stretch>
         </p:blipFill>
         <p:spPr>
-          <a:xfrm>
-            <a:off x="91440" y="3657600"/>
-            <a:ext cx="1257163" cy="1417320"/>
+          <a:xfrm flipH="1">
+            <a:off x="91440" y="3653028"/>
+            <a:ext cx="1422989" cy="1417320"/>
           </a:xfrm>
           <a:prstGeom prst="rect">
             <a:avLst/>
@@ -18167,7 +18143,7 @@
       </p:pic>
       <p:pic>
         <p:nvPicPr>
-          <p:cNvPr id="23" name="Image 1" descr="rabbit">    </p:cNvPr>
+          <p:cNvPr id="23" name="Image 1" descr="parrot">    </p:cNvPr>
           <p:cNvPicPr>
             <a:picLocks noChangeAspect="1"/>
           </p:cNvPicPr>
@@ -18181,8 +18157,32 @@
         </p:blipFill>
         <p:spPr>
           <a:xfrm>
-            <a:off x="7975305" y="3520440"/>
-            <a:ext cx="1077255" cy="1554480"/>
+            <a:off x="7712598" y="3515868"/>
+            <a:ext cx="1339962" cy="1554480"/>
+          </a:xfrm>
+          <a:prstGeom prst="rect">
+            <a:avLst/>
+          </a:prstGeom>
+        </p:spPr>
+      </p:pic>
+      <p:pic>
+        <p:nvPicPr>
+          <p:cNvPr id="24" name="Image 2" descr="dove">    </p:cNvPr>
+          <p:cNvPicPr>
+            <a:picLocks noChangeAspect="1"/>
+          </p:cNvPicPr>
+          <p:nvPr/>
+        </p:nvPicPr>
+        <p:blipFill>
+          <a:blip r:embed="rId3"/>
+          <a:stretch>
+            <a:fillRect/>
+          </a:stretch>
+        </p:blipFill>
+        <p:spPr>
+          <a:xfrm>
+            <a:off x="4803709" y="45720"/>
+            <a:ext cx="774131" cy="777240"/>
           </a:xfrm>
           <a:prstGeom prst="rect">
             <a:avLst/>
@@ -19173,7 +19173,7 @@
       </p:sp>
       <p:pic>
         <p:nvPicPr>
-          <p:cNvPr id="20" name="Image 0" descr="turtle">    </p:cNvPr>
+          <p:cNvPr id="20" name="Image 0" descr="dolphin">    </p:cNvPr>
           <p:cNvPicPr>
             <a:picLocks noChangeAspect="1"/>
           </p:cNvPicPr>
@@ -19186,9 +19186,9 @@
           </a:stretch>
         </p:blipFill>
         <p:spPr>
-          <a:xfrm>
-            <a:off x="91440" y="3657600"/>
-            <a:ext cx="1452753" cy="1417320"/>
+          <a:xfrm flipH="1">
+            <a:off x="91440" y="3653028"/>
+            <a:ext cx="1114014" cy="1417320"/>
           </a:xfrm>
           <a:prstGeom prst="rect">
             <a:avLst/>
@@ -19197,7 +19197,7 @@
       </p:pic>
       <p:pic>
         <p:nvPicPr>
-          <p:cNvPr id="21" name="Image 1" descr="dog">    </p:cNvPr>
+          <p:cNvPr id="21" name="Image 1" descr="crab">    </p:cNvPr>
           <p:cNvPicPr>
             <a:picLocks noChangeAspect="1"/>
           </p:cNvPicPr>
@@ -19211,8 +19211,8 @@
         </p:blipFill>
         <p:spPr>
           <a:xfrm>
-            <a:off x="7672182" y="3520440"/>
-            <a:ext cx="1380378" cy="1554480"/>
+            <a:off x="7311542" y="3515868"/>
+            <a:ext cx="1741018" cy="1554480"/>
           </a:xfrm>
           <a:prstGeom prst="rect">
             <a:avLst/>
@@ -19221,7 +19221,7 @@
       </p:pic>
       <p:pic>
         <p:nvPicPr>
-          <p:cNvPr id="22" name="Image 2" descr="bird1">    </p:cNvPr>
+          <p:cNvPr id="22" name="Image 2" descr="honeybee">    </p:cNvPr>
           <p:cNvPicPr>
             <a:picLocks noChangeAspect="1"/>
           </p:cNvPicPr>
@@ -19235,8 +19235,8 @@
         </p:blipFill>
         <p:spPr>
           <a:xfrm flipH="1">
-            <a:off x="6216457" y="45720"/>
-            <a:ext cx="1007303" cy="777240"/>
+            <a:off x="1920240" y="45720"/>
+            <a:ext cx="825429" cy="777240"/>
           </a:xfrm>
           <a:prstGeom prst="rect">
             <a:avLst/>
@@ -20417,7 +20417,7 @@
       </p:sp>
       <p:pic>
         <p:nvPicPr>
-          <p:cNvPr id="28" name="Image 0" descr="bird4">    </p:cNvPr>
+          <p:cNvPr id="28" name="Image 0" descr="lady_beetle">    </p:cNvPr>
           <p:cNvPicPr>
             <a:picLocks noChangeAspect="1"/>
           </p:cNvPicPr>
@@ -20431,8 +20431,8 @@
         </p:blipFill>
         <p:spPr>
           <a:xfrm>
-            <a:off x="1005840" y="45720"/>
-            <a:ext cx="1007303" cy="777240"/>
+            <a:off x="4797491" y="45720"/>
+            <a:ext cx="780349" cy="777240"/>
           </a:xfrm>
           <a:prstGeom prst="rect">
             <a:avLst/>
@@ -21441,7 +21441,7 @@
       </p:sp>
       <p:pic>
         <p:nvPicPr>
-          <p:cNvPr id="22" name="Image 0" descr="fish">    </p:cNvPr>
+          <p:cNvPr id="22" name="Image 0" descr="hippopotamus">    </p:cNvPr>
           <p:cNvPicPr>
             <a:picLocks noChangeAspect="1"/>
           </p:cNvPicPr>
@@ -21454,9 +21454,9 @@
           </a:stretch>
         </p:blipFill>
         <p:spPr>
-          <a:xfrm>
-            <a:off x="91440" y="1783080"/>
-            <a:ext cx="1932219" cy="1554480"/>
+          <a:xfrm flipH="1">
+            <a:off x="91440" y="1828800"/>
+            <a:ext cx="2276490" cy="1463040"/>
           </a:xfrm>
           <a:prstGeom prst="rect">
             <a:avLst/>
@@ -21465,7 +21465,7 @@
       </p:pic>
       <p:pic>
         <p:nvPicPr>
-          <p:cNvPr id="23" name="Image 1" descr="dog">    </p:cNvPr>
+          <p:cNvPr id="23" name="Image 1" descr="llama">    </p:cNvPr>
           <p:cNvPicPr>
             <a:picLocks noChangeAspect="1"/>
           </p:cNvPicPr>
@@ -21479,8 +21479,8 @@
         </p:blipFill>
         <p:spPr>
           <a:xfrm>
-            <a:off x="7655082" y="1783080"/>
-            <a:ext cx="1397478" cy="1554480"/>
+            <a:off x="7687544" y="1828800"/>
+            <a:ext cx="1365016" cy="1463040"/>
           </a:xfrm>
           <a:prstGeom prst="rect">
             <a:avLst/>
@@ -21489,7 +21489,7 @@
       </p:pic>
       <p:pic>
         <p:nvPicPr>
-          <p:cNvPr id="24" name="Image 2" descr="bee">    </p:cNvPr>
+          <p:cNvPr id="24" name="Image 2" descr="bird">    </p:cNvPr>
           <p:cNvPicPr>
             <a:picLocks noChangeAspect="1"/>
           </p:cNvPicPr>
@@ -21502,9 +21502,9 @@
           </a:stretch>
         </p:blipFill>
         <p:spPr>
-          <a:xfrm>
-            <a:off x="5507248" y="45720"/>
-            <a:ext cx="802112" cy="777240"/>
+          <a:xfrm flipH="1">
+            <a:off x="2834640" y="45720"/>
+            <a:ext cx="742264" cy="777240"/>
           </a:xfrm>
           <a:prstGeom prst="rect">
             <a:avLst/>
@@ -22314,7 +22314,7 @@
       </p:sp>
       <p:pic>
         <p:nvPicPr>
-          <p:cNvPr id="17" name="Image 0" descr="elephant">    </p:cNvPr>
+          <p:cNvPr id="17" name="Image 0" descr="peacock">    </p:cNvPr>
           <p:cNvPicPr>
             <a:picLocks noChangeAspect="1"/>
           </p:cNvPicPr>
@@ -22328,8 +22328,8 @@
         </p:blipFill>
         <p:spPr>
           <a:xfrm>
-            <a:off x="91440" y="1783080"/>
-            <a:ext cx="1713037" cy="1554480"/>
+            <a:off x="91440" y="1828800"/>
+            <a:ext cx="1561064" cy="1463040"/>
           </a:xfrm>
           <a:prstGeom prst="rect">
             <a:avLst/>
@@ -22338,7 +22338,7 @@
       </p:pic>
       <p:pic>
         <p:nvPicPr>
-          <p:cNvPr id="18" name="Image 1" descr="dog">    </p:cNvPr>
+          <p:cNvPr id="18" name="Image 1" descr="duck">    </p:cNvPr>
           <p:cNvPicPr>
             <a:picLocks noChangeAspect="1"/>
           </p:cNvPicPr>
@@ -22352,8 +22352,8 @@
         </p:blipFill>
         <p:spPr>
           <a:xfrm>
-            <a:off x="7583576" y="1783080"/>
-            <a:ext cx="1468984" cy="1554480"/>
+            <a:off x="7589520" y="1828800"/>
+            <a:ext cx="1463040" cy="1463040"/>
           </a:xfrm>
           <a:prstGeom prst="rect">
             <a:avLst/>
@@ -22362,7 +22362,7 @@
       </p:pic>
       <p:pic>
         <p:nvPicPr>
-          <p:cNvPr id="19" name="Image 2" descr="bird2">    </p:cNvPr>
+          <p:cNvPr id="19" name="Image 2" descr="butterfly">    </p:cNvPr>
           <p:cNvPicPr>
             <a:picLocks noChangeAspect="1"/>
           </p:cNvPicPr>
@@ -22376,8 +22376,8 @@
         </p:blipFill>
         <p:spPr>
           <a:xfrm>
-            <a:off x="1920240" y="45720"/>
-            <a:ext cx="918789" cy="731520"/>
+            <a:off x="5760720" y="45720"/>
+            <a:ext cx="548640" cy="548640"/>
           </a:xfrm>
           <a:prstGeom prst="rect">
             <a:avLst/>
@@ -23212,7 +23212,7 @@
       </p:sp>
       <p:pic>
         <p:nvPicPr>
-          <p:cNvPr id="18" name="Image 0" descr="duck">    </p:cNvPr>
+          <p:cNvPr id="18" name="Image 0" descr="zebra">    </p:cNvPr>
           <p:cNvPicPr>
             <a:picLocks noChangeAspect="1"/>
           </p:cNvPicPr>
@@ -23226,8 +23226,8 @@
         </p:blipFill>
         <p:spPr>
           <a:xfrm>
-            <a:off x="91440" y="1783080"/>
-            <a:ext cx="1313536" cy="1554480"/>
+            <a:off x="91440" y="1828800"/>
+            <a:ext cx="1463040" cy="1463040"/>
           </a:xfrm>
           <a:prstGeom prst="rect">
             <a:avLst/>
@@ -23236,7 +23236,7 @@
       </p:pic>
       <p:pic>
         <p:nvPicPr>
-          <p:cNvPr id="19" name="Image 1" descr="rabbit">    </p:cNvPr>
+          <p:cNvPr id="19" name="Image 1" descr="snail">    </p:cNvPr>
           <p:cNvPicPr>
             <a:picLocks noChangeAspect="1"/>
           </p:cNvPicPr>
@@ -23249,9 +23249,9 @@
           </a:stretch>
         </p:blipFill>
         <p:spPr>
-          <a:xfrm>
-            <a:off x="7841620" y="1783080"/>
-            <a:ext cx="1210940" cy="1554480"/>
+          <a:xfrm flipH="1">
+            <a:off x="7563185" y="1828800"/>
+            <a:ext cx="1489375" cy="1463040"/>
           </a:xfrm>
           <a:prstGeom prst="rect">
             <a:avLst/>
@@ -23260,7 +23260,7 @@
       </p:pic>
       <p:pic>
         <p:nvPicPr>
-          <p:cNvPr id="20" name="Image 2" descr="butterfly1">    </p:cNvPr>
+          <p:cNvPr id="20" name="Image 2" descr="dove">    </p:cNvPr>
           <p:cNvPicPr>
             <a:picLocks noChangeAspect="1"/>
           </p:cNvPicPr>
@@ -23273,9 +23273,9 @@
           </a:stretch>
         </p:blipFill>
         <p:spPr>
-          <a:xfrm>
-            <a:off x="5403098" y="45720"/>
-            <a:ext cx="906262" cy="777240"/>
+          <a:xfrm flipH="1">
+            <a:off x="1920240" y="45720"/>
+            <a:ext cx="774131" cy="777240"/>
           </a:xfrm>
           <a:prstGeom prst="rect">
             <a:avLst/>
@@ -24148,9 +24148,9 @@
           </a:stretch>
         </p:blipFill>
         <p:spPr>
-          <a:xfrm>
-            <a:off x="91440" y="1783080"/>
-            <a:ext cx="1468984" cy="1554480"/>
+          <a:xfrm flipH="1">
+            <a:off x="91440" y="1828800"/>
+            <a:ext cx="1638605" cy="1463040"/>
           </a:xfrm>
           <a:prstGeom prst="rect">
             <a:avLst/>
@@ -24159,7 +24159,7 @@
       </p:pic>
       <p:pic>
         <p:nvPicPr>
-          <p:cNvPr id="20" name="Image 1" descr="rabbit">    </p:cNvPr>
+          <p:cNvPr id="20" name="Image 1" descr="hippopotamus">    </p:cNvPr>
           <p:cNvPicPr>
             <a:picLocks noChangeAspect="1"/>
           </p:cNvPicPr>
@@ -24173,8 +24173,32 @@
         </p:blipFill>
         <p:spPr>
           <a:xfrm>
-            <a:off x="7894472" y="1783080"/>
-            <a:ext cx="1158088" cy="1554480"/>
+            <a:off x="6776070" y="1828800"/>
+            <a:ext cx="2276490" cy="1463040"/>
+          </a:xfrm>
+          <a:prstGeom prst="rect">
+            <a:avLst/>
+          </a:prstGeom>
+        </p:spPr>
+      </p:pic>
+      <p:pic>
+        <p:nvPicPr>
+          <p:cNvPr id="21" name="Image 2" descr="honeybee">    </p:cNvPr>
+          <p:cNvPicPr>
+            <a:picLocks noChangeAspect="1"/>
+          </p:cNvPicPr>
+          <p:nvPr/>
+        </p:nvPicPr>
+        <p:blipFill>
+          <a:blip r:embed="rId3"/>
+          <a:stretch>
+            <a:fillRect/>
+          </a:stretch>
+        </p:blipFill>
+        <p:spPr>
+          <a:xfrm>
+            <a:off x="4752411" y="45720"/>
+            <a:ext cx="825429" cy="777240"/>
           </a:xfrm>
           <a:prstGeom prst="rect">
             <a:avLst/>
@@ -25093,7 +25117,7 @@
       </p:sp>
       <p:pic>
         <p:nvPicPr>
-          <p:cNvPr id="20" name="Image 0" descr="cat">    </p:cNvPr>
+          <p:cNvPr id="20" name="Image 0" descr="tropical_fish">    </p:cNvPr>
           <p:cNvPicPr>
             <a:picLocks noChangeAspect="1"/>
           </p:cNvPicPr>
@@ -25106,9 +25130,9 @@
           </a:stretch>
         </p:blipFill>
         <p:spPr>
-          <a:xfrm>
-            <a:off x="91440" y="3657600"/>
-            <a:ext cx="1206139" cy="1417320"/>
+          <a:xfrm flipH="1">
+            <a:off x="91440" y="3653028"/>
+            <a:ext cx="1724878" cy="1417320"/>
           </a:xfrm>
           <a:prstGeom prst="rect">
             <a:avLst/>
@@ -25117,7 +25141,7 @@
       </p:pic>
       <p:pic>
         <p:nvPicPr>
-          <p:cNvPr id="21" name="Image 1" descr="rabbit">    </p:cNvPr>
+          <p:cNvPr id="21" name="Image 1" descr="duck">    </p:cNvPr>
           <p:cNvPicPr>
             <a:picLocks noChangeAspect="1"/>
           </p:cNvPicPr>
@@ -25131,8 +25155,8 @@
         </p:blipFill>
         <p:spPr>
           <a:xfrm>
-            <a:off x="7875819" y="3520440"/>
-            <a:ext cx="1176741" cy="1554480"/>
+            <a:off x="7498080" y="3515868"/>
+            <a:ext cx="1554480" cy="1554480"/>
           </a:xfrm>
           <a:prstGeom prst="rect">
             <a:avLst/>
@@ -25141,7 +25165,7 @@
       </p:pic>
       <p:pic>
         <p:nvPicPr>
-          <p:cNvPr id="22" name="Image 2" descr="bee">    </p:cNvPr>
+          <p:cNvPr id="22" name="Image 2" descr="bird">    </p:cNvPr>
           <p:cNvPicPr>
             <a:picLocks noChangeAspect="1"/>
           </p:cNvPicPr>
@@ -25154,9 +25178,9 @@
           </a:stretch>
         </p:blipFill>
         <p:spPr>
-          <a:xfrm>
-            <a:off x="6421648" y="45720"/>
-            <a:ext cx="802112" cy="777240"/>
+          <a:xfrm flipH="1">
+            <a:off x="1920240" y="45720"/>
+            <a:ext cx="742264" cy="777240"/>
           </a:xfrm>
           <a:prstGeom prst="rect">
             <a:avLst/>
@@ -26337,7 +26361,7 @@
       </p:sp>
       <p:pic>
         <p:nvPicPr>
-          <p:cNvPr id="28" name="Image 0" descr="bird2">    </p:cNvPr>
+          <p:cNvPr id="28" name="Image 0" descr="butterfly">    </p:cNvPr>
           <p:cNvPicPr>
             <a:picLocks noChangeAspect="1"/>
           </p:cNvPicPr>
@@ -26351,8 +26375,8 @@
         </p:blipFill>
         <p:spPr>
           <a:xfrm>
-            <a:off x="1005840" y="45720"/>
-            <a:ext cx="976213" cy="777240"/>
+            <a:off x="4800600" y="45720"/>
+            <a:ext cx="777240" cy="777240"/>
           </a:xfrm>
           <a:prstGeom prst="rect">
             <a:avLst/>
@@ -27460,7 +27484,7 @@
       </p:sp>
       <p:pic>
         <p:nvPicPr>
-          <p:cNvPr id="25" name="Image 0" descr="turtle">    </p:cNvPr>
+          <p:cNvPr id="25" name="Image 0" descr="ewe">    </p:cNvPr>
           <p:cNvPicPr>
             <a:picLocks noChangeAspect="1"/>
           </p:cNvPicPr>
@@ -27473,9 +27497,9 @@
           </a:stretch>
         </p:blipFill>
         <p:spPr>
-          <a:xfrm>
-            <a:off x="91440" y="4206240"/>
-            <a:ext cx="890397" cy="868680"/>
+          <a:xfrm flipH="1">
+            <a:off x="91440" y="4155948"/>
+            <a:ext cx="914400" cy="914400"/>
           </a:xfrm>
           <a:prstGeom prst="rect">
             <a:avLst/>
@@ -27484,7 +27508,7 @@
       </p:pic>
       <p:pic>
         <p:nvPicPr>
-          <p:cNvPr id="26" name="Image 1" descr="butterfly1">    </p:cNvPr>
+          <p:cNvPr id="26" name="Image 1" descr="dove">    </p:cNvPr>
           <p:cNvPicPr>
             <a:picLocks noChangeAspect="1"/>
           </p:cNvPicPr>
@@ -27497,9 +27521,9 @@
           </a:stretch>
         </p:blipFill>
         <p:spPr>
-          <a:xfrm>
-            <a:off x="5456408" y="45720"/>
-            <a:ext cx="852952" cy="731520"/>
+          <a:xfrm flipH="1">
+            <a:off x="2834640" y="45720"/>
+            <a:ext cx="774131" cy="777240"/>
           </a:xfrm>
           <a:prstGeom prst="rect">
             <a:avLst/>
@@ -28480,7 +28504,7 @@
       </p:sp>
       <p:pic>
         <p:nvPicPr>
-          <p:cNvPr id="20" name="Image 0" descr="rabbit">    </p:cNvPr>
+          <p:cNvPr id="20" name="Image 0" descr="horse">    </p:cNvPr>
           <p:cNvPicPr>
             <a:picLocks noChangeAspect="1"/>
           </p:cNvPicPr>
@@ -28493,9 +28517,9 @@
           </a:stretch>
         </p:blipFill>
         <p:spPr>
-          <a:xfrm>
-            <a:off x="91440" y="3657600"/>
-            <a:ext cx="1060155" cy="1417320"/>
+          <a:xfrm flipH="1">
+            <a:off x="91440" y="3653028"/>
+            <a:ext cx="1417320" cy="1417320"/>
           </a:xfrm>
           <a:prstGeom prst="rect">
             <a:avLst/>
@@ -28504,7 +28528,7 @@
       </p:pic>
       <p:pic>
         <p:nvPicPr>
-          <p:cNvPr id="21" name="Image 1" descr="dog">    </p:cNvPr>
+          <p:cNvPr id="21" name="Image 1" descr="rooster">    </p:cNvPr>
           <p:cNvPicPr>
             <a:picLocks noChangeAspect="1"/>
           </p:cNvPicPr>
@@ -28518,8 +28542,8 @@
         </p:blipFill>
         <p:spPr>
           <a:xfrm>
-            <a:off x="7599121" y="3520440"/>
-            <a:ext cx="1453439" cy="1554480"/>
+            <a:off x="7554041" y="3515868"/>
+            <a:ext cx="1498519" cy="1554480"/>
           </a:xfrm>
           <a:prstGeom prst="rect">
             <a:avLst/>
@@ -28528,7 +28552,7 @@
       </p:pic>
       <p:pic>
         <p:nvPicPr>
-          <p:cNvPr id="22" name="Image 2" descr="bird1">    </p:cNvPr>
+          <p:cNvPr id="22" name="Image 2" descr="honeybee">    </p:cNvPr>
           <p:cNvPicPr>
             <a:picLocks noChangeAspect="1"/>
           </p:cNvPicPr>
@@ -28542,8 +28566,8 @@
         </p:blipFill>
         <p:spPr>
           <a:xfrm>
-            <a:off x="1920240" y="45720"/>
-            <a:ext cx="888797" cy="685800"/>
+            <a:off x="5775259" y="45720"/>
+            <a:ext cx="534101" cy="502920"/>
           </a:xfrm>
           <a:prstGeom prst="rect">
             <a:avLst/>
@@ -29549,7 +29573,7 @@
       </p:sp>
       <p:pic>
         <p:nvPicPr>
-          <p:cNvPr id="21" name="Image 0" descr="fish">    </p:cNvPr>
+          <p:cNvPr id="21" name="Image 0" descr="penguin">    </p:cNvPr>
           <p:cNvPicPr>
             <a:picLocks noChangeAspect="1"/>
           </p:cNvPicPr>
@@ -29563,8 +29587,8 @@
         </p:blipFill>
         <p:spPr>
           <a:xfrm>
-            <a:off x="91440" y="4206240"/>
-            <a:ext cx="1079769" cy="868680"/>
+            <a:off x="91440" y="3973068"/>
+            <a:ext cx="1109350" cy="1097280"/>
           </a:xfrm>
           <a:prstGeom prst="rect">
             <a:avLst/>
@@ -29573,7 +29597,7 @@
       </p:pic>
       <p:pic>
         <p:nvPicPr>
-          <p:cNvPr id="22" name="Image 1" descr="dog">    </p:cNvPr>
+          <p:cNvPr id="22" name="Image 1" descr="lady_beetle">    </p:cNvPr>
           <p:cNvPicPr>
             <a:picLocks noChangeAspect="1"/>
           </p:cNvPicPr>
@@ -29587,32 +29611,8 @@
         </p:blipFill>
         <p:spPr>
           <a:xfrm>
-            <a:off x="8353821" y="4297680"/>
-            <a:ext cx="698739" cy="777240"/>
-          </a:xfrm>
-          <a:prstGeom prst="rect">
-            <a:avLst/>
-          </a:prstGeom>
-        </p:spPr>
-      </p:pic>
-      <p:pic>
-        <p:nvPicPr>
-          <p:cNvPr id="23" name="Image 2" descr="bird4">    </p:cNvPr>
-          <p:cNvPicPr>
-            <a:picLocks noChangeAspect="1"/>
-          </p:cNvPicPr>
-          <p:nvPr/>
-        </p:nvPicPr>
-        <p:blipFill>
-          <a:blip r:embed="rId3"/>
-          <a:stretch>
-            <a:fillRect/>
-          </a:stretch>
-        </p:blipFill>
-        <p:spPr>
-          <a:xfrm flipH="1">
-            <a:off x="5302057" y="45720"/>
-            <a:ext cx="1007303" cy="777240"/>
+            <a:off x="1920240" y="45720"/>
+            <a:ext cx="780349" cy="777240"/>
           </a:xfrm>
           <a:prstGeom prst="rect">
             <a:avLst/>
@@ -30643,7 +30643,7 @@
       </p:sp>
       <p:pic>
         <p:nvPicPr>
-          <p:cNvPr id="22" name="Image 0" descr="elephant">    </p:cNvPr>
+          <p:cNvPr id="22" name="Image 0" descr="baby_chick">    </p:cNvPr>
           <p:cNvPicPr>
             <a:picLocks noChangeAspect="1"/>
           </p:cNvPicPr>
@@ -30656,9 +30656,9 @@
           </a:stretch>
         </p:blipFill>
         <p:spPr>
-          <a:xfrm>
-            <a:off x="91440" y="3657600"/>
-            <a:ext cx="1561887" cy="1417320"/>
+          <a:xfrm flipH="1">
+            <a:off x="91440" y="3653028"/>
+            <a:ext cx="1526454" cy="1417320"/>
           </a:xfrm>
           <a:prstGeom prst="rect">
             <a:avLst/>
@@ -30667,7 +30667,7 @@
       </p:pic>
       <p:pic>
         <p:nvPicPr>
-          <p:cNvPr id="23" name="Image 1" descr="dog">    </p:cNvPr>
+          <p:cNvPr id="23" name="Image 1" descr="chipmunk">    </p:cNvPr>
           <p:cNvPicPr>
             <a:picLocks noChangeAspect="1"/>
           </p:cNvPicPr>
@@ -30681,8 +30681,32 @@
         </p:blipFill>
         <p:spPr>
           <a:xfrm>
-            <a:off x="7583576" y="3520440"/>
-            <a:ext cx="1468984" cy="1554480"/>
+            <a:off x="7440564" y="3515868"/>
+            <a:ext cx="1611996" cy="1554480"/>
+          </a:xfrm>
+          <a:prstGeom prst="rect">
+            <a:avLst/>
+          </a:prstGeom>
+        </p:spPr>
+      </p:pic>
+      <p:pic>
+        <p:nvPicPr>
+          <p:cNvPr id="24" name="Image 2" descr="bird">    </p:cNvPr>
+          <p:cNvPicPr>
+            <a:picLocks noChangeAspect="1"/>
+          </p:cNvPicPr>
+          <p:nvPr/>
+        </p:nvPicPr>
+        <p:blipFill>
+          <a:blip r:embed="rId3"/>
+          <a:stretch>
+            <a:fillRect/>
+          </a:stretch>
+        </p:blipFill>
+        <p:spPr>
+          <a:xfrm>
+            <a:off x="4835576" y="45720"/>
+            <a:ext cx="742264" cy="777240"/>
           </a:xfrm>
           <a:prstGeom prst="rect">
             <a:avLst/>
@@ -31801,7 +31825,7 @@
       </p:sp>
       <p:pic>
         <p:nvPicPr>
-          <p:cNvPr id="24" name="Image 0" descr="duck">    </p:cNvPr>
+          <p:cNvPr id="24" name="Image 0" descr="penguin">    </p:cNvPr>
           <p:cNvPicPr>
             <a:picLocks noChangeAspect="1"/>
           </p:cNvPicPr>
@@ -31815,8 +31839,8 @@
         </p:blipFill>
         <p:spPr>
           <a:xfrm>
-            <a:off x="91440" y="3566160"/>
-            <a:ext cx="1274902" cy="1508760"/>
+            <a:off x="91440" y="3561588"/>
+            <a:ext cx="1525356" cy="1508760"/>
           </a:xfrm>
           <a:prstGeom prst="rect">
             <a:avLst/>
@@ -31825,7 +31849,7 @@
       </p:pic>
       <p:pic>
         <p:nvPicPr>
-          <p:cNvPr id="25" name="Image 1" descr="rabbit">    </p:cNvPr>
+          <p:cNvPr id="25" name="Image 1" descr="octopus">    </p:cNvPr>
           <p:cNvPicPr>
             <a:picLocks noChangeAspect="1"/>
           </p:cNvPicPr>
@@ -31839,8 +31863,8 @@
         </p:blipFill>
         <p:spPr>
           <a:xfrm>
-            <a:off x="7699157" y="3337560"/>
-            <a:ext cx="1353403" cy="1737360"/>
+            <a:off x="7259604" y="3332988"/>
+            <a:ext cx="1792956" cy="1737360"/>
           </a:xfrm>
           <a:prstGeom prst="rect">
             <a:avLst/>
@@ -31849,7 +31873,7 @@
       </p:pic>
       <p:pic>
         <p:nvPicPr>
-          <p:cNvPr id="26" name="Image 2" descr="bird2">    </p:cNvPr>
+          <p:cNvPr id="26" name="Image 2" descr="butterfly">    </p:cNvPr>
           <p:cNvPicPr>
             <a:picLocks noChangeAspect="1"/>
           </p:cNvPicPr>
@@ -31862,9 +31886,9 @@
           </a:stretch>
         </p:blipFill>
         <p:spPr>
-          <a:xfrm flipH="1">
-            <a:off x="6247547" y="45720"/>
-            <a:ext cx="976213" cy="777240"/>
+          <a:xfrm>
+            <a:off x="1920240" y="45720"/>
+            <a:ext cx="777240" cy="777240"/>
           </a:xfrm>
           <a:prstGeom prst="rect">
             <a:avLst/>

</xml_diff>

<commit_message>
Use the user's own kids, animals and birds in fathah, kasrah and dammah decks
characters/: the three 10x10 grids, cut.py (cuts them, removes the white background, turns floor shadows see-through), 296 pictures and friends.js, which puts each friend in the biggest free spot. Replaces the Fluent emoji set.

Co-Authored-By: Claude Opus 5.5 <noreply@anthropic.com>
Claude-Session: https://claude.ai/code/session_01XjTEwQ8YdBa1SjcPiYTm9z
</commit_message>
<xml_diff>
--- a/dammah-plus/01-alif.pptx
+++ b/dammah-plus/01-alif.pptx
@@ -3430,7 +3430,7 @@
       </p:sp>
       <p:pic>
         <p:nvPicPr>
-          <p:cNvPr id="14" name="Image 0" descr="giraffe">    </p:cNvPr>
+          <p:cNvPr id="14" name="Image 0" descr="animal">    </p:cNvPr>
           <p:cNvPicPr>
             <a:picLocks noChangeAspect="1"/>
           </p:cNvPicPr>
@@ -3443,9 +3443,9 @@
           </a:stretch>
         </p:blipFill>
         <p:spPr>
-          <a:xfrm flipH="1">
-            <a:off x="91440" y="1828800"/>
-            <a:ext cx="1372332" cy="1463040"/>
+          <a:xfrm>
+            <a:off x="91440" y="2011680"/>
+            <a:ext cx="2832720" cy="1188720"/>
           </a:xfrm>
           <a:prstGeom prst="rect">
             <a:avLst/>
@@ -3454,7 +3454,7 @@
       </p:pic>
       <p:pic>
         <p:nvPicPr>
-          <p:cNvPr id="15" name="Image 1" descr="owl">    </p:cNvPr>
+          <p:cNvPr id="15" name="Image 1" descr="bird">    </p:cNvPr>
           <p:cNvPicPr>
             <a:picLocks noChangeAspect="1"/>
           </p:cNvPicPr>
@@ -3468,32 +3468,8 @@
         </p:blipFill>
         <p:spPr>
           <a:xfrm>
-            <a:off x="7902611" y="1828800"/>
-            <a:ext cx="1149949" cy="1463040"/>
-          </a:xfrm>
-          <a:prstGeom prst="rect">
-            <a:avLst/>
-          </a:prstGeom>
-        </p:spPr>
-      </p:pic>
-      <p:pic>
-        <p:nvPicPr>
-          <p:cNvPr id="16" name="Image 2" descr="honeybee">    </p:cNvPr>
-          <p:cNvPicPr>
-            <a:picLocks noChangeAspect="1"/>
-          </p:cNvPicPr>
-          <p:nvPr/>
-        </p:nvPicPr>
-        <p:blipFill>
-          <a:blip r:embed="rId3"/>
-          <a:stretch>
-            <a:fillRect/>
-          </a:stretch>
-        </p:blipFill>
-        <p:spPr>
-          <a:xfrm flipH="1">
-            <a:off x="1920240" y="45720"/>
-            <a:ext cx="825429" cy="777240"/>
+            <a:off x="7349033" y="1783080"/>
+            <a:ext cx="1703527" cy="1645920"/>
           </a:xfrm>
           <a:prstGeom prst="rect">
             <a:avLst/>
@@ -4525,30 +4501,6 @@
           </a:p>
         </p:txBody>
       </p:sp>
-      <p:pic>
-        <p:nvPicPr>
-          <p:cNvPr id="32" name="Image 0" descr="dove">    </p:cNvPr>
-          <p:cNvPicPr>
-            <a:picLocks noChangeAspect="1"/>
-          </p:cNvPicPr>
-          <p:nvPr/>
-        </p:nvPicPr>
-        <p:blipFill>
-          <a:blip r:embed="rId1"/>
-          <a:stretch>
-            <a:fillRect/>
-          </a:stretch>
-        </p:blipFill>
-        <p:spPr>
-          <a:xfrm>
-            <a:off x="4803709" y="45720"/>
-            <a:ext cx="774131" cy="777240"/>
-          </a:xfrm>
-          <a:prstGeom prst="rect">
-            <a:avLst/>
-          </a:prstGeom>
-        </p:spPr>
-      </p:pic>
     </p:spTree>
   </p:cSld>
   <p:clrMapOvr>
@@ -5940,7 +5892,7 @@
       </p:sp>
       <p:pic>
         <p:nvPicPr>
-          <p:cNvPr id="29" name="Image 0" descr="parrot">    </p:cNvPr>
+          <p:cNvPr id="29" name="Image 0" descr="animal">    </p:cNvPr>
           <p:cNvPicPr>
             <a:picLocks noChangeAspect="1"/>
           </p:cNvPicPr>
@@ -5953,9 +5905,9 @@
           </a:stretch>
         </p:blipFill>
         <p:spPr>
-          <a:xfrm flipH="1">
-            <a:off x="91440" y="4018788"/>
-            <a:ext cx="906445" cy="1051560"/>
+          <a:xfrm>
+            <a:off x="91440" y="3835908"/>
+            <a:ext cx="904845" cy="1234440"/>
           </a:xfrm>
           <a:prstGeom prst="rect">
             <a:avLst/>
@@ -5964,7 +5916,7 @@
       </p:pic>
       <p:pic>
         <p:nvPicPr>
-          <p:cNvPr id="30" name="Image 1" descr="honeybee">    </p:cNvPr>
+          <p:cNvPr id="30" name="Image 1" descr="kid">    </p:cNvPr>
           <p:cNvPicPr>
             <a:picLocks noChangeAspect="1"/>
           </p:cNvPicPr>
@@ -5977,9 +5929,9 @@
           </a:stretch>
         </p:blipFill>
         <p:spPr>
-          <a:xfrm flipH="1">
-            <a:off x="2834640" y="45720"/>
-            <a:ext cx="825429" cy="777240"/>
+          <a:xfrm>
+            <a:off x="8476305" y="4018788"/>
+            <a:ext cx="576255" cy="1051560"/>
           </a:xfrm>
           <a:prstGeom prst="rect">
             <a:avLst/>
@@ -7250,7 +7202,7 @@
       </p:sp>
       <p:pic>
         <p:nvPicPr>
-          <p:cNvPr id="24" name="Image 0" descr="turtle">    </p:cNvPr>
+          <p:cNvPr id="24" name="Image 0" descr="kid">    </p:cNvPr>
           <p:cNvPicPr>
             <a:picLocks noChangeAspect="1"/>
           </p:cNvPicPr>
@@ -7263,9 +7215,9 @@
           </a:stretch>
         </p:blipFill>
         <p:spPr>
-          <a:xfrm flipH="1">
+          <a:xfrm>
             <a:off x="91440" y="3561588"/>
-            <a:ext cx="2432121" cy="1508760"/>
+            <a:ext cx="858484" cy="1508760"/>
           </a:xfrm>
           <a:prstGeom prst="rect">
             <a:avLst/>
@@ -7274,7 +7226,7 @@
       </p:pic>
       <p:pic>
         <p:nvPicPr>
-          <p:cNvPr id="25" name="Image 1" descr="monkey">    </p:cNvPr>
+          <p:cNvPr id="25" name="Image 1" descr="bird">    </p:cNvPr>
           <p:cNvPicPr>
             <a:picLocks noChangeAspect="1"/>
           </p:cNvPicPr>
@@ -7288,32 +7240,8 @@
         </p:blipFill>
         <p:spPr>
           <a:xfrm>
-            <a:off x="7075444" y="3332988"/>
-            <a:ext cx="1977116" cy="1737360"/>
-          </a:xfrm>
-          <a:prstGeom prst="rect">
-            <a:avLst/>
-          </a:prstGeom>
-        </p:spPr>
-      </p:pic>
-      <p:pic>
-        <p:nvPicPr>
-          <p:cNvPr id="26" name="Image 2" descr="lady_beetle">    </p:cNvPr>
-          <p:cNvPicPr>
-            <a:picLocks noChangeAspect="1"/>
-          </p:cNvPicPr>
-          <p:nvPr/>
-        </p:nvPicPr>
-        <p:blipFill>
-          <a:blip r:embed="rId3"/>
-          <a:stretch>
-            <a:fillRect/>
-          </a:stretch>
-        </p:blipFill>
-        <p:spPr>
-          <a:xfrm>
-            <a:off x="5758525" y="45720"/>
-            <a:ext cx="550835" cy="548640"/>
+            <a:off x="7662672" y="3332988"/>
+            <a:ext cx="1389888" cy="1737360"/>
           </a:xfrm>
           <a:prstGeom prst="rect">
             <a:avLst/>
@@ -8609,7 +8537,7 @@
       </p:sp>
       <p:pic>
         <p:nvPicPr>
-          <p:cNvPr id="25" name="Image 0" descr="deer">    </p:cNvPr>
+          <p:cNvPr id="25" name="Image 0" descr="animal">    </p:cNvPr>
           <p:cNvPicPr>
             <a:picLocks noChangeAspect="1"/>
           </p:cNvPicPr>
@@ -8622,33 +8550,9 @@
           </a:stretch>
         </p:blipFill>
         <p:spPr>
-          <a:xfrm flipH="1">
-            <a:off x="91440" y="3973068"/>
-            <a:ext cx="1097280" cy="1097280"/>
-          </a:xfrm>
-          <a:prstGeom prst="rect">
-            <a:avLst/>
-          </a:prstGeom>
-        </p:spPr>
-      </p:pic>
-      <p:pic>
-        <p:nvPicPr>
-          <p:cNvPr id="26" name="Image 1" descr="bird">    </p:cNvPr>
-          <p:cNvPicPr>
-            <a:picLocks noChangeAspect="1"/>
-          </p:cNvPicPr>
-          <p:nvPr/>
-        </p:nvPicPr>
-        <p:blipFill>
-          <a:blip r:embed="rId2"/>
-          <a:stretch>
-            <a:fillRect/>
-          </a:stretch>
-        </p:blipFill>
-        <p:spPr>
-          <a:xfrm flipH="1">
-            <a:off x="1920240" y="45720"/>
-            <a:ext cx="742264" cy="777240"/>
+          <a:xfrm>
+            <a:off x="91440" y="4064508"/>
+            <a:ext cx="1083290" cy="1005840"/>
           </a:xfrm>
           <a:prstGeom prst="rect">
             <a:avLst/>
@@ -9969,7 +9873,7 @@
       </p:sp>
       <p:pic>
         <p:nvPicPr>
-          <p:cNvPr id="26" name="Image 0" descr="goat">    </p:cNvPr>
+          <p:cNvPr id="26" name="Image 0" descr="kid">    </p:cNvPr>
           <p:cNvPicPr>
             <a:picLocks noChangeAspect="1"/>
           </p:cNvPicPr>
@@ -9984,7 +9888,7 @@
         <p:spPr>
           <a:xfrm>
             <a:off x="91440" y="3561588"/>
-            <a:ext cx="1615882" cy="1508760"/>
+            <a:ext cx="843397" cy="1508760"/>
           </a:xfrm>
           <a:prstGeom prst="rect">
             <a:avLst/>
@@ -9993,7 +9897,7 @@
       </p:pic>
       <p:pic>
         <p:nvPicPr>
-          <p:cNvPr id="27" name="Image 1" descr="swan">    </p:cNvPr>
+          <p:cNvPr id="27" name="Image 1" descr="kid">    </p:cNvPr>
           <p:cNvPicPr>
             <a:picLocks noChangeAspect="1"/>
           </p:cNvPicPr>
@@ -10007,32 +9911,8 @@
         </p:blipFill>
         <p:spPr>
           <a:xfrm>
-            <a:off x="7181423" y="3332988"/>
-            <a:ext cx="1871137" cy="1737360"/>
-          </a:xfrm>
-          <a:prstGeom prst="rect">
-            <a:avLst/>
-          </a:prstGeom>
-        </p:spPr>
-      </p:pic>
-      <p:pic>
-        <p:nvPicPr>
-          <p:cNvPr id="28" name="Image 2" descr="butterfly">    </p:cNvPr>
-          <p:cNvPicPr>
-            <a:picLocks noChangeAspect="1"/>
-          </p:cNvPicPr>
-          <p:nvPr/>
-        </p:nvPicPr>
-        <p:blipFill>
-          <a:blip r:embed="rId3"/>
-          <a:stretch>
-            <a:fillRect/>
-          </a:stretch>
-        </p:blipFill>
-        <p:spPr>
-          <a:xfrm>
-            <a:off x="4800600" y="45720"/>
-            <a:ext cx="777240" cy="777240"/>
+            <a:off x="8057053" y="3332988"/>
+            <a:ext cx="995507" cy="1737360"/>
           </a:xfrm>
           <a:prstGeom prst="rect">
             <a:avLst/>
@@ -11313,7 +11193,7 @@
       </p:sp>
       <p:pic>
         <p:nvPicPr>
-          <p:cNvPr id="24" name="Image 0" descr="swan">    </p:cNvPr>
+          <p:cNvPr id="24" name="Image 0" descr="animal">    </p:cNvPr>
           <p:cNvPicPr>
             <a:picLocks noChangeAspect="1"/>
           </p:cNvPicPr>
@@ -11326,9 +11206,9 @@
           </a:stretch>
         </p:blipFill>
         <p:spPr>
-          <a:xfrm flipH="1">
+          <a:xfrm>
             <a:off x="91440" y="3561588"/>
-            <a:ext cx="1624935" cy="1508760"/>
+            <a:ext cx="1409182" cy="1508760"/>
           </a:xfrm>
           <a:prstGeom prst="rect">
             <a:avLst/>
@@ -11337,7 +11217,7 @@
       </p:pic>
       <p:pic>
         <p:nvPicPr>
-          <p:cNvPr id="25" name="Image 1" descr="turtle">    </p:cNvPr>
+          <p:cNvPr id="25" name="Image 1" descr="sea">    </p:cNvPr>
           <p:cNvPicPr>
             <a:picLocks noChangeAspect="1"/>
           </p:cNvPicPr>
@@ -11351,32 +11231,8 @@
         </p:blipFill>
         <p:spPr>
           <a:xfrm>
-            <a:off x="6251936" y="3332988"/>
-            <a:ext cx="2800624" cy="1737360"/>
-          </a:xfrm>
-          <a:prstGeom prst="rect">
-            <a:avLst/>
-          </a:prstGeom>
-        </p:spPr>
-      </p:pic>
-      <p:pic>
-        <p:nvPicPr>
-          <p:cNvPr id="26" name="Image 2" descr="dove">    </p:cNvPr>
-          <p:cNvPicPr>
-            <a:picLocks noChangeAspect="1"/>
-          </p:cNvPicPr>
-          <p:nvPr/>
-        </p:nvPicPr>
-        <p:blipFill>
-          <a:blip r:embed="rId3"/>
-          <a:stretch>
-            <a:fillRect/>
-          </a:stretch>
-        </p:blipFill>
-        <p:spPr>
-          <a:xfrm flipH="1">
-            <a:off x="1920240" y="45720"/>
-            <a:ext cx="774131" cy="777240"/>
+            <a:off x="8150870" y="3332988"/>
+            <a:ext cx="901690" cy="1737360"/>
           </a:xfrm>
           <a:prstGeom prst="rect">
             <a:avLst/>
@@ -12717,30 +12573,6 @@
           </a:p>
         </p:txBody>
       </p:sp>
-      <p:pic>
-        <p:nvPicPr>
-          <p:cNvPr id="28" name="Image 0" descr="honeybee">    </p:cNvPr>
-          <p:cNvPicPr>
-            <a:picLocks noChangeAspect="1"/>
-          </p:cNvPicPr>
-          <p:nvPr/>
-        </p:nvPicPr>
-        <p:blipFill>
-          <a:blip r:embed="rId1"/>
-          <a:stretch>
-            <a:fillRect/>
-          </a:stretch>
-        </p:blipFill>
-        <p:spPr>
-          <a:xfrm>
-            <a:off x="4752411" y="45720"/>
-            <a:ext cx="825429" cy="777240"/>
-          </a:xfrm>
-          <a:prstGeom prst="rect">
-            <a:avLst/>
-          </a:prstGeom>
-        </p:spPr>
-      </p:pic>
     </p:spTree>
   </p:cSld>
   <p:clrMapOvr>
@@ -13842,7 +13674,7 @@
       </p:sp>
       <p:pic>
         <p:nvPicPr>
-          <p:cNvPr id="25" name="Image 0" descr="chipmunk">    </p:cNvPr>
+          <p:cNvPr id="25" name="Image 0" descr="kid">    </p:cNvPr>
           <p:cNvPicPr>
             <a:picLocks noChangeAspect="1"/>
           </p:cNvPicPr>
@@ -13855,33 +13687,9 @@
           </a:stretch>
         </p:blipFill>
         <p:spPr>
-          <a:xfrm flipH="1">
-            <a:off x="91440" y="4201668"/>
-            <a:ext cx="900821" cy="868680"/>
-          </a:xfrm>
-          <a:prstGeom prst="rect">
-            <a:avLst/>
-          </a:prstGeom>
-        </p:spPr>
-      </p:pic>
-      <p:pic>
-        <p:nvPicPr>
-          <p:cNvPr id="26" name="Image 1" descr="lady_beetle">    </p:cNvPr>
-          <p:cNvPicPr>
-            <a:picLocks noChangeAspect="1"/>
-          </p:cNvPicPr>
-          <p:nvPr/>
-        </p:nvPicPr>
-        <p:blipFill>
-          <a:blip r:embed="rId2"/>
-          <a:stretch>
-            <a:fillRect/>
-          </a:stretch>
-        </p:blipFill>
-        <p:spPr>
-          <a:xfrm>
-            <a:off x="2834640" y="45720"/>
-            <a:ext cx="780349" cy="777240"/>
+          <a:xfrm>
+            <a:off x="8473928" y="3790188"/>
+            <a:ext cx="578632" cy="1280160"/>
           </a:xfrm>
           <a:prstGeom prst="rect">
             <a:avLst/>
@@ -14862,7 +14670,7 @@
       </p:sp>
       <p:pic>
         <p:nvPicPr>
-          <p:cNvPr id="20" name="Image 0" descr="flamingo">    </p:cNvPr>
+          <p:cNvPr id="20" name="Image 0" descr="kid">    </p:cNvPr>
           <p:cNvPicPr>
             <a:picLocks noChangeAspect="1"/>
           </p:cNvPicPr>
@@ -14875,9 +14683,9 @@
           </a:stretch>
         </p:blipFill>
         <p:spPr>
-          <a:xfrm flipH="1">
+          <a:xfrm>
             <a:off x="91440" y="3653028"/>
-            <a:ext cx="1106927" cy="1417320"/>
+            <a:ext cx="907085" cy="1417320"/>
           </a:xfrm>
           <a:prstGeom prst="rect">
             <a:avLst/>
@@ -14886,7 +14694,7 @@
       </p:pic>
       <p:pic>
         <p:nvPicPr>
-          <p:cNvPr id="21" name="Image 1" descr="hatching_chick">    </p:cNvPr>
+          <p:cNvPr id="21" name="Image 1" descr="bird">    </p:cNvPr>
           <p:cNvPicPr>
             <a:picLocks noChangeAspect="1"/>
           </p:cNvPicPr>
@@ -14900,32 +14708,8 @@
         </p:blipFill>
         <p:spPr>
           <a:xfrm>
-            <a:off x="7498080" y="3515868"/>
-            <a:ext cx="1554480" cy="1554480"/>
-          </a:xfrm>
-          <a:prstGeom prst="rect">
-            <a:avLst/>
-          </a:prstGeom>
-        </p:spPr>
-      </p:pic>
-      <p:pic>
-        <p:nvPicPr>
-          <p:cNvPr id="22" name="Image 2" descr="bird">    </p:cNvPr>
-          <p:cNvPicPr>
-            <a:picLocks noChangeAspect="1"/>
-          </p:cNvPicPr>
-          <p:nvPr/>
-        </p:nvPicPr>
-        <p:blipFill>
-          <a:blip r:embed="rId3"/>
-          <a:stretch>
-            <a:fillRect/>
-          </a:stretch>
-        </p:blipFill>
-        <p:spPr>
-          <a:xfrm>
-            <a:off x="5785409" y="45720"/>
-            <a:ext cx="523951" cy="548640"/>
+            <a:off x="7552487" y="3515868"/>
+            <a:ext cx="1500073" cy="1554480"/>
           </a:xfrm>
           <a:prstGeom prst="rect">
             <a:avLst/>
@@ -15931,7 +15715,7 @@
       </p:sp>
       <p:pic>
         <p:nvPicPr>
-          <p:cNvPr id="21" name="Image 0" descr="kangaroo">    </p:cNvPr>
+          <p:cNvPr id="21" name="Image 0" descr="animal">    </p:cNvPr>
           <p:cNvPicPr>
             <a:picLocks noChangeAspect="1"/>
           </p:cNvPicPr>
@@ -15945,56 +15729,8 @@
         </p:blipFill>
         <p:spPr>
           <a:xfrm>
-            <a:off x="91440" y="4064508"/>
-            <a:ext cx="1078260" cy="1005840"/>
-          </a:xfrm>
-          <a:prstGeom prst="rect">
-            <a:avLst/>
-          </a:prstGeom>
-        </p:spPr>
-      </p:pic>
-      <p:pic>
-        <p:nvPicPr>
-          <p:cNvPr id="22" name="Image 1" descr="cat">    </p:cNvPr>
-          <p:cNvPicPr>
-            <a:picLocks noChangeAspect="1"/>
-          </p:cNvPicPr>
-          <p:nvPr/>
-        </p:nvPicPr>
-        <p:blipFill>
-          <a:blip r:embed="rId2"/>
-          <a:stretch>
-            <a:fillRect/>
-          </a:stretch>
-        </p:blipFill>
-        <p:spPr>
-          <a:xfrm>
-            <a:off x="8341385" y="4384548"/>
-            <a:ext cx="711175" cy="685800"/>
-          </a:xfrm>
-          <a:prstGeom prst="rect">
-            <a:avLst/>
-          </a:prstGeom>
-        </p:spPr>
-      </p:pic>
-      <p:pic>
-        <p:nvPicPr>
-          <p:cNvPr id="23" name="Image 2" descr="butterfly">    </p:cNvPr>
-          <p:cNvPicPr>
-            <a:picLocks noChangeAspect="1"/>
-          </p:cNvPicPr>
-          <p:nvPr/>
-        </p:nvPicPr>
-        <p:blipFill>
-          <a:blip r:embed="rId3"/>
-          <a:stretch>
-            <a:fillRect/>
-          </a:stretch>
-        </p:blipFill>
-        <p:spPr>
-          <a:xfrm>
-            <a:off x="1920240" y="45720"/>
-            <a:ext cx="777240" cy="777240"/>
+            <a:off x="91440" y="3790188"/>
+            <a:ext cx="1112459" cy="1280160"/>
           </a:xfrm>
           <a:prstGeom prst="rect">
             <a:avLst/>
@@ -17025,7 +16761,7 @@
       </p:sp>
       <p:pic>
         <p:nvPicPr>
-          <p:cNvPr id="22" name="Image 0" descr="llama">    </p:cNvPr>
+          <p:cNvPr id="22" name="Image 0" descr="kid">    </p:cNvPr>
           <p:cNvPicPr>
             <a:picLocks noChangeAspect="1"/>
           </p:cNvPicPr>
@@ -17038,9 +16774,9 @@
           </a:stretch>
         </p:blipFill>
         <p:spPr>
-          <a:xfrm flipH="1">
+          <a:xfrm>
             <a:off x="91440" y="3653028"/>
-            <a:ext cx="1322360" cy="1417320"/>
+            <a:ext cx="673227" cy="1417320"/>
           </a:xfrm>
           <a:prstGeom prst="rect">
             <a:avLst/>
@@ -17049,7 +16785,7 @@
       </p:pic>
       <p:pic>
         <p:nvPicPr>
-          <p:cNvPr id="23" name="Image 1" descr="ewe">    </p:cNvPr>
+          <p:cNvPr id="23" name="Image 1" descr="kid">    </p:cNvPr>
           <p:cNvPicPr>
             <a:picLocks noChangeAspect="1"/>
           </p:cNvPicPr>
@@ -17063,32 +16799,8 @@
         </p:blipFill>
         <p:spPr>
           <a:xfrm>
-            <a:off x="7498080" y="3515868"/>
-            <a:ext cx="1554480" cy="1554480"/>
-          </a:xfrm>
-          <a:prstGeom prst="rect">
-            <a:avLst/>
-          </a:prstGeom>
-        </p:spPr>
-      </p:pic>
-      <p:pic>
-        <p:nvPicPr>
-          <p:cNvPr id="24" name="Image 2" descr="lady_beetle">    </p:cNvPr>
-          <p:cNvPicPr>
-            <a:picLocks noChangeAspect="1"/>
-          </p:cNvPicPr>
-          <p:nvPr/>
-        </p:nvPicPr>
-        <p:blipFill>
-          <a:blip r:embed="rId3"/>
-          <a:stretch>
-            <a:fillRect/>
-          </a:stretch>
-        </p:blipFill>
-        <p:spPr>
-          <a:xfrm>
-            <a:off x="4797491" y="45720"/>
-            <a:ext cx="780349" cy="777240"/>
+            <a:off x="8161843" y="3515868"/>
+            <a:ext cx="890717" cy="1554480"/>
           </a:xfrm>
           <a:prstGeom prst="rect">
             <a:avLst/>
@@ -18119,7 +17831,7 @@
       </p:sp>
       <p:pic>
         <p:nvPicPr>
-          <p:cNvPr id="22" name="Image 0" descr="rabbit">    </p:cNvPr>
+          <p:cNvPr id="22" name="Image 0" descr="kid">    </p:cNvPr>
           <p:cNvPicPr>
             <a:picLocks noChangeAspect="1"/>
           </p:cNvPicPr>
@@ -18132,9 +17844,9 @@
           </a:stretch>
         </p:blipFill>
         <p:spPr>
-          <a:xfrm flipH="1">
+          <a:xfrm>
             <a:off x="91440" y="3653028"/>
-            <a:ext cx="1422989" cy="1417320"/>
+            <a:ext cx="643463" cy="1417320"/>
           </a:xfrm>
           <a:prstGeom prst="rect">
             <a:avLst/>
@@ -18143,7 +17855,7 @@
       </p:pic>
       <p:pic>
         <p:nvPicPr>
-          <p:cNvPr id="23" name="Image 1" descr="parrot">    </p:cNvPr>
+          <p:cNvPr id="23" name="Image 1" descr="kid">    </p:cNvPr>
           <p:cNvPicPr>
             <a:picLocks noChangeAspect="1"/>
           </p:cNvPicPr>
@@ -18157,32 +17869,8 @@
         </p:blipFill>
         <p:spPr>
           <a:xfrm>
-            <a:off x="7712598" y="3515868"/>
-            <a:ext cx="1339962" cy="1554480"/>
-          </a:xfrm>
-          <a:prstGeom prst="rect">
-            <a:avLst/>
-          </a:prstGeom>
-        </p:spPr>
-      </p:pic>
-      <p:pic>
-        <p:nvPicPr>
-          <p:cNvPr id="24" name="Image 2" descr="dove">    </p:cNvPr>
-          <p:cNvPicPr>
-            <a:picLocks noChangeAspect="1"/>
-          </p:cNvPicPr>
-          <p:nvPr/>
-        </p:nvPicPr>
-        <p:blipFill>
-          <a:blip r:embed="rId3"/>
-          <a:stretch>
-            <a:fillRect/>
-          </a:stretch>
-        </p:blipFill>
-        <p:spPr>
-          <a:xfrm>
-            <a:off x="4803709" y="45720"/>
-            <a:ext cx="774131" cy="777240"/>
+            <a:off x="7913126" y="3515868"/>
+            <a:ext cx="1139434" cy="1554480"/>
           </a:xfrm>
           <a:prstGeom prst="rect">
             <a:avLst/>
@@ -19173,7 +18861,7 @@
       </p:sp>
       <p:pic>
         <p:nvPicPr>
-          <p:cNvPr id="20" name="Image 0" descr="dolphin">    </p:cNvPr>
+          <p:cNvPr id="20" name="Image 0" descr="animal">    </p:cNvPr>
           <p:cNvPicPr>
             <a:picLocks noChangeAspect="1"/>
           </p:cNvPicPr>
@@ -19186,9 +18874,9 @@
           </a:stretch>
         </p:blipFill>
         <p:spPr>
-          <a:xfrm flipH="1">
+          <a:xfrm>
             <a:off x="91440" y="3653028"/>
-            <a:ext cx="1114014" cy="1417320"/>
+            <a:ext cx="1279840" cy="1417320"/>
           </a:xfrm>
           <a:prstGeom prst="rect">
             <a:avLst/>
@@ -19197,7 +18885,7 @@
       </p:pic>
       <p:pic>
         <p:nvPicPr>
-          <p:cNvPr id="21" name="Image 1" descr="crab">    </p:cNvPr>
+          <p:cNvPr id="21" name="Image 1" descr="sea">    </p:cNvPr>
           <p:cNvPicPr>
             <a:picLocks noChangeAspect="1"/>
           </p:cNvPicPr>
@@ -19211,32 +18899,8 @@
         </p:blipFill>
         <p:spPr>
           <a:xfrm>
-            <a:off x="7311542" y="3515868"/>
-            <a:ext cx="1741018" cy="1554480"/>
-          </a:xfrm>
-          <a:prstGeom prst="rect">
-            <a:avLst/>
-          </a:prstGeom>
-        </p:spPr>
-      </p:pic>
-      <p:pic>
-        <p:nvPicPr>
-          <p:cNvPr id="22" name="Image 2" descr="honeybee">    </p:cNvPr>
-          <p:cNvPicPr>
-            <a:picLocks noChangeAspect="1"/>
-          </p:cNvPicPr>
-          <p:nvPr/>
-        </p:nvPicPr>
-        <p:blipFill>
-          <a:blip r:embed="rId3"/>
-          <a:stretch>
-            <a:fillRect/>
-          </a:stretch>
-        </p:blipFill>
-        <p:spPr>
-          <a:xfrm flipH="1">
-            <a:off x="1920240" y="45720"/>
-            <a:ext cx="825429" cy="777240"/>
+            <a:off x="6736385" y="3515868"/>
+            <a:ext cx="2316175" cy="1554480"/>
           </a:xfrm>
           <a:prstGeom prst="rect">
             <a:avLst/>
@@ -20415,30 +20079,6 @@
           </a:p>
         </p:txBody>
       </p:sp>
-      <p:pic>
-        <p:nvPicPr>
-          <p:cNvPr id="28" name="Image 0" descr="lady_beetle">    </p:cNvPr>
-          <p:cNvPicPr>
-            <a:picLocks noChangeAspect="1"/>
-          </p:cNvPicPr>
-          <p:nvPr/>
-        </p:nvPicPr>
-        <p:blipFill>
-          <a:blip r:embed="rId1"/>
-          <a:stretch>
-            <a:fillRect/>
-          </a:stretch>
-        </p:blipFill>
-        <p:spPr>
-          <a:xfrm>
-            <a:off x="4797491" y="45720"/>
-            <a:ext cx="780349" cy="777240"/>
-          </a:xfrm>
-          <a:prstGeom prst="rect">
-            <a:avLst/>
-          </a:prstGeom>
-        </p:spPr>
-      </p:pic>
     </p:spTree>
   </p:cSld>
   <p:clrMapOvr>
@@ -21441,7 +21081,7 @@
       </p:sp>
       <p:pic>
         <p:nvPicPr>
-          <p:cNvPr id="22" name="Image 0" descr="hippopotamus">    </p:cNvPr>
+          <p:cNvPr id="22" name="Image 0" descr="animal">    </p:cNvPr>
           <p:cNvPicPr>
             <a:picLocks noChangeAspect="1"/>
           </p:cNvPicPr>
@@ -21454,9 +21094,9 @@
           </a:stretch>
         </p:blipFill>
         <p:spPr>
-          <a:xfrm flipH="1">
-            <a:off x="91440" y="1828800"/>
-            <a:ext cx="2276490" cy="1463040"/>
+          <a:xfrm>
+            <a:off x="91440" y="1783080"/>
+            <a:ext cx="1711757" cy="1645920"/>
           </a:xfrm>
           <a:prstGeom prst="rect">
             <a:avLst/>
@@ -21465,7 +21105,7 @@
       </p:pic>
       <p:pic>
         <p:nvPicPr>
-          <p:cNvPr id="23" name="Image 1" descr="llama">    </p:cNvPr>
+          <p:cNvPr id="23" name="Image 1" descr="kid">    </p:cNvPr>
           <p:cNvPicPr>
             <a:picLocks noChangeAspect="1"/>
           </p:cNvPicPr>
@@ -21479,32 +21119,8 @@
         </p:blipFill>
         <p:spPr>
           <a:xfrm>
-            <a:off x="7687544" y="1828800"/>
-            <a:ext cx="1365016" cy="1463040"/>
-          </a:xfrm>
-          <a:prstGeom prst="rect">
-            <a:avLst/>
-          </a:prstGeom>
-        </p:spPr>
-      </p:pic>
-      <p:pic>
-        <p:nvPicPr>
-          <p:cNvPr id="24" name="Image 2" descr="bird">    </p:cNvPr>
-          <p:cNvPicPr>
-            <a:picLocks noChangeAspect="1"/>
-          </p:cNvPicPr>
-          <p:nvPr/>
-        </p:nvPicPr>
-        <p:blipFill>
-          <a:blip r:embed="rId3"/>
-          <a:stretch>
-            <a:fillRect/>
-          </a:stretch>
-        </p:blipFill>
-        <p:spPr>
-          <a:xfrm flipH="1">
-            <a:off x="2834640" y="45720"/>
-            <a:ext cx="742264" cy="777240"/>
+            <a:off x="8176931" y="1783080"/>
+            <a:ext cx="875629" cy="1645920"/>
           </a:xfrm>
           <a:prstGeom prst="rect">
             <a:avLst/>
@@ -22314,7 +21930,7 @@
       </p:sp>
       <p:pic>
         <p:nvPicPr>
-          <p:cNvPr id="17" name="Image 0" descr="peacock">    </p:cNvPr>
+          <p:cNvPr id="17" name="Image 0" descr="kid">    </p:cNvPr>
           <p:cNvPicPr>
             <a:picLocks noChangeAspect="1"/>
           </p:cNvPicPr>
@@ -22328,8 +21944,8 @@
         </p:blipFill>
         <p:spPr>
           <a:xfrm>
-            <a:off x="91440" y="1828800"/>
-            <a:ext cx="1561064" cy="1463040"/>
+            <a:off x="91440" y="3241548"/>
+            <a:ext cx="830275" cy="1828800"/>
           </a:xfrm>
           <a:prstGeom prst="rect">
             <a:avLst/>
@@ -22338,7 +21954,7 @@
       </p:pic>
       <p:pic>
         <p:nvPicPr>
-          <p:cNvPr id="18" name="Image 1" descr="duck">    </p:cNvPr>
+          <p:cNvPr id="18" name="Image 1" descr="bird">    </p:cNvPr>
           <p:cNvPicPr>
             <a:picLocks noChangeAspect="1"/>
           </p:cNvPicPr>
@@ -22352,32 +21968,8 @@
         </p:blipFill>
         <p:spPr>
           <a:xfrm>
-            <a:off x="7589520" y="1828800"/>
-            <a:ext cx="1463040" cy="1463040"/>
-          </a:xfrm>
-          <a:prstGeom prst="rect">
-            <a:avLst/>
-          </a:prstGeom>
-        </p:spPr>
-      </p:pic>
-      <p:pic>
-        <p:nvPicPr>
-          <p:cNvPr id="19" name="Image 2" descr="butterfly">    </p:cNvPr>
-          <p:cNvPicPr>
-            <a:picLocks noChangeAspect="1"/>
-          </p:cNvPicPr>
-          <p:nvPr/>
-        </p:nvPicPr>
-        <p:blipFill>
-          <a:blip r:embed="rId3"/>
-          <a:stretch>
-            <a:fillRect/>
-          </a:stretch>
-        </p:blipFill>
-        <p:spPr>
-          <a:xfrm>
-            <a:off x="5760720" y="45720"/>
-            <a:ext cx="548640" cy="548640"/>
+            <a:off x="7706563" y="3241548"/>
+            <a:ext cx="1345997" cy="1828800"/>
           </a:xfrm>
           <a:prstGeom prst="rect">
             <a:avLst/>
@@ -23212,7 +22804,7 @@
       </p:sp>
       <p:pic>
         <p:nvPicPr>
-          <p:cNvPr id="18" name="Image 0" descr="zebra">    </p:cNvPr>
+          <p:cNvPr id="18" name="Image 0" descr="animal">    </p:cNvPr>
           <p:cNvPicPr>
             <a:picLocks noChangeAspect="1"/>
           </p:cNvPicPr>
@@ -23226,8 +22818,8 @@
         </p:blipFill>
         <p:spPr>
           <a:xfrm>
-            <a:off x="91440" y="1828800"/>
-            <a:ext cx="1463040" cy="1463040"/>
+            <a:off x="91440" y="1783080"/>
+            <a:ext cx="1601480" cy="1645920"/>
           </a:xfrm>
           <a:prstGeom prst="rect">
             <a:avLst/>
@@ -23236,7 +22828,7 @@
       </p:pic>
       <p:pic>
         <p:nvPicPr>
-          <p:cNvPr id="19" name="Image 1" descr="snail">    </p:cNvPr>
+          <p:cNvPr id="19" name="Image 1" descr="bird">    </p:cNvPr>
           <p:cNvPicPr>
             <a:picLocks noChangeAspect="1"/>
           </p:cNvPicPr>
@@ -23249,33 +22841,9 @@
           </a:stretch>
         </p:blipFill>
         <p:spPr>
-          <a:xfrm flipH="1">
-            <a:off x="7563185" y="1828800"/>
-            <a:ext cx="1489375" cy="1463040"/>
-          </a:xfrm>
-          <a:prstGeom prst="rect">
-            <a:avLst/>
-          </a:prstGeom>
-        </p:spPr>
-      </p:pic>
-      <p:pic>
-        <p:nvPicPr>
-          <p:cNvPr id="20" name="Image 2" descr="dove">    </p:cNvPr>
-          <p:cNvPicPr>
-            <a:picLocks noChangeAspect="1"/>
-          </p:cNvPicPr>
-          <p:nvPr/>
-        </p:nvPicPr>
-        <p:blipFill>
-          <a:blip r:embed="rId3"/>
-          <a:stretch>
-            <a:fillRect/>
-          </a:stretch>
-        </p:blipFill>
-        <p:spPr>
-          <a:xfrm flipH="1">
-            <a:off x="1920240" y="45720"/>
-            <a:ext cx="774131" cy="777240"/>
+          <a:xfrm>
+            <a:off x="7584399" y="1783080"/>
+            <a:ext cx="1468161" cy="1645920"/>
           </a:xfrm>
           <a:prstGeom prst="rect">
             <a:avLst/>
@@ -24135,7 +23703,7 @@
       </p:sp>
       <p:pic>
         <p:nvPicPr>
-          <p:cNvPr id="19" name="Image 0" descr="dog">    </p:cNvPr>
+          <p:cNvPr id="19" name="Image 0" descr="kid">    </p:cNvPr>
           <p:cNvPicPr>
             <a:picLocks noChangeAspect="1"/>
           </p:cNvPicPr>
@@ -24148,9 +23716,9 @@
           </a:stretch>
         </p:blipFill>
         <p:spPr>
-          <a:xfrm flipH="1">
-            <a:off x="91440" y="1828800"/>
-            <a:ext cx="1638605" cy="1463040"/>
+          <a:xfrm>
+            <a:off x="91440" y="3241548"/>
+            <a:ext cx="780898" cy="1828800"/>
           </a:xfrm>
           <a:prstGeom prst="rect">
             <a:avLst/>
@@ -24159,7 +23727,7 @@
       </p:pic>
       <p:pic>
         <p:nvPicPr>
-          <p:cNvPr id="20" name="Image 1" descr="hippopotamus">    </p:cNvPr>
+          <p:cNvPr id="20" name="Image 1" descr="kid">    </p:cNvPr>
           <p:cNvPicPr>
             <a:picLocks noChangeAspect="1"/>
           </p:cNvPicPr>
@@ -24173,32 +23741,8 @@
         </p:blipFill>
         <p:spPr>
           <a:xfrm>
-            <a:off x="6776070" y="1828800"/>
-            <a:ext cx="2276490" cy="1463040"/>
-          </a:xfrm>
-          <a:prstGeom prst="rect">
-            <a:avLst/>
-          </a:prstGeom>
-        </p:spPr>
-      </p:pic>
-      <p:pic>
-        <p:nvPicPr>
-          <p:cNvPr id="21" name="Image 2" descr="honeybee">    </p:cNvPr>
-          <p:cNvPicPr>
-            <a:picLocks noChangeAspect="1"/>
-          </p:cNvPicPr>
-          <p:nvPr/>
-        </p:nvPicPr>
-        <p:blipFill>
-          <a:blip r:embed="rId3"/>
-          <a:stretch>
-            <a:fillRect/>
-          </a:stretch>
-        </p:blipFill>
-        <p:spPr>
-          <a:xfrm>
-            <a:off x="4752411" y="45720"/>
-            <a:ext cx="825429" cy="777240"/>
+            <a:off x="7993685" y="3241548"/>
+            <a:ext cx="1058875" cy="1828800"/>
           </a:xfrm>
           <a:prstGeom prst="rect">
             <a:avLst/>
@@ -25117,7 +24661,7 @@
       </p:sp>
       <p:pic>
         <p:nvPicPr>
-          <p:cNvPr id="20" name="Image 0" descr="tropical_fish">    </p:cNvPr>
+          <p:cNvPr id="20" name="Image 0" descr="animal">    </p:cNvPr>
           <p:cNvPicPr>
             <a:picLocks noChangeAspect="1"/>
           </p:cNvPicPr>
@@ -25130,9 +24674,9 @@
           </a:stretch>
         </p:blipFill>
         <p:spPr>
-          <a:xfrm flipH="1">
+          <a:xfrm>
             <a:off x="91440" y="3653028"/>
-            <a:ext cx="1724878" cy="1417320"/>
+            <a:ext cx="1564721" cy="1417320"/>
           </a:xfrm>
           <a:prstGeom prst="rect">
             <a:avLst/>
@@ -25141,7 +24685,7 @@
       </p:pic>
       <p:pic>
         <p:nvPicPr>
-          <p:cNvPr id="21" name="Image 1" descr="duck">    </p:cNvPr>
+          <p:cNvPr id="21" name="Image 1" descr="sea">    </p:cNvPr>
           <p:cNvPicPr>
             <a:picLocks noChangeAspect="1"/>
           </p:cNvPicPr>
@@ -25155,32 +24699,8 @@
         </p:blipFill>
         <p:spPr>
           <a:xfrm>
-            <a:off x="7498080" y="3515868"/>
-            <a:ext cx="1554480" cy="1554480"/>
-          </a:xfrm>
-          <a:prstGeom prst="rect">
-            <a:avLst/>
-          </a:prstGeom>
-        </p:spPr>
-      </p:pic>
-      <p:pic>
-        <p:nvPicPr>
-          <p:cNvPr id="22" name="Image 2" descr="bird">    </p:cNvPr>
-          <p:cNvPicPr>
-            <a:picLocks noChangeAspect="1"/>
-          </p:cNvPicPr>
-          <p:nvPr/>
-        </p:nvPicPr>
-        <p:blipFill>
-          <a:blip r:embed="rId3"/>
-          <a:stretch>
-            <a:fillRect/>
-          </a:stretch>
-        </p:blipFill>
-        <p:spPr>
-          <a:xfrm flipH="1">
-            <a:off x="1920240" y="45720"/>
-            <a:ext cx="742264" cy="777240"/>
+            <a:off x="6736385" y="3515868"/>
+            <a:ext cx="2316175" cy="1554480"/>
           </a:xfrm>
           <a:prstGeom prst="rect">
             <a:avLst/>
@@ -26361,7 +25881,7 @@
       </p:sp>
       <p:pic>
         <p:nvPicPr>
-          <p:cNvPr id="28" name="Image 0" descr="butterfly">    </p:cNvPr>
+          <p:cNvPr id="28" name="Image 0" descr="kid">    </p:cNvPr>
           <p:cNvPicPr>
             <a:picLocks noChangeAspect="1"/>
           </p:cNvPicPr>
@@ -26375,8 +25895,8 @@
         </p:blipFill>
         <p:spPr>
           <a:xfrm>
-            <a:off x="4800600" y="45720"/>
-            <a:ext cx="777240" cy="777240"/>
+            <a:off x="91440" y="2103120"/>
+            <a:ext cx="510967" cy="1005840"/>
           </a:xfrm>
           <a:prstGeom prst="rect">
             <a:avLst/>
@@ -27484,7 +27004,7 @@
       </p:sp>
       <p:pic>
         <p:nvPicPr>
-          <p:cNvPr id="25" name="Image 0" descr="ewe">    </p:cNvPr>
+          <p:cNvPr id="25" name="Image 0" descr="kid">    </p:cNvPr>
           <p:cNvPicPr>
             <a:picLocks noChangeAspect="1"/>
           </p:cNvPicPr>
@@ -27497,33 +27017,9 @@
           </a:stretch>
         </p:blipFill>
         <p:spPr>
-          <a:xfrm flipH="1">
-            <a:off x="91440" y="4155948"/>
-            <a:ext cx="914400" cy="914400"/>
-          </a:xfrm>
-          <a:prstGeom prst="rect">
-            <a:avLst/>
-          </a:prstGeom>
-        </p:spPr>
-      </p:pic>
-      <p:pic>
-        <p:nvPicPr>
-          <p:cNvPr id="26" name="Image 1" descr="dove">    </p:cNvPr>
-          <p:cNvPicPr>
-            <a:picLocks noChangeAspect="1"/>
-          </p:cNvPicPr>
-          <p:nvPr/>
-        </p:nvPicPr>
-        <p:blipFill>
-          <a:blip r:embed="rId2"/>
-          <a:stretch>
-            <a:fillRect/>
-          </a:stretch>
-        </p:blipFill>
-        <p:spPr>
-          <a:xfrm flipH="1">
-            <a:off x="2834640" y="45720"/>
-            <a:ext cx="774131" cy="777240"/>
+          <a:xfrm>
+            <a:off x="8470087" y="3790188"/>
+            <a:ext cx="582473" cy="1280160"/>
           </a:xfrm>
           <a:prstGeom prst="rect">
             <a:avLst/>
@@ -28504,7 +28000,7 @@
       </p:sp>
       <p:pic>
         <p:nvPicPr>
-          <p:cNvPr id="20" name="Image 0" descr="horse">    </p:cNvPr>
+          <p:cNvPr id="20" name="Image 0" descr="kid">    </p:cNvPr>
           <p:cNvPicPr>
             <a:picLocks noChangeAspect="1"/>
           </p:cNvPicPr>
@@ -28517,9 +28013,9 @@
           </a:stretch>
         </p:blipFill>
         <p:spPr>
-          <a:xfrm flipH="1">
+          <a:xfrm>
             <a:off x="91440" y="3653028"/>
-            <a:ext cx="1417320" cy="1417320"/>
+            <a:ext cx="629290" cy="1417320"/>
           </a:xfrm>
           <a:prstGeom prst="rect">
             <a:avLst/>
@@ -28528,7 +28024,7 @@
       </p:pic>
       <p:pic>
         <p:nvPicPr>
-          <p:cNvPr id="21" name="Image 1" descr="rooster">    </p:cNvPr>
+          <p:cNvPr id="21" name="Image 1" descr="bird">    </p:cNvPr>
           <p:cNvPicPr>
             <a:picLocks noChangeAspect="1"/>
           </p:cNvPicPr>
@@ -28542,32 +28038,8 @@
         </p:blipFill>
         <p:spPr>
           <a:xfrm>
-            <a:off x="7554041" y="3515868"/>
-            <a:ext cx="1498519" cy="1554480"/>
-          </a:xfrm>
-          <a:prstGeom prst="rect">
-            <a:avLst/>
-          </a:prstGeom>
-        </p:spPr>
-      </p:pic>
-      <p:pic>
-        <p:nvPicPr>
-          <p:cNvPr id="22" name="Image 2" descr="honeybee">    </p:cNvPr>
-          <p:cNvPicPr>
-            <a:picLocks noChangeAspect="1"/>
-          </p:cNvPicPr>
-          <p:nvPr/>
-        </p:nvPicPr>
-        <p:blipFill>
-          <a:blip r:embed="rId3"/>
-          <a:stretch>
-            <a:fillRect/>
-          </a:stretch>
-        </p:blipFill>
-        <p:spPr>
-          <a:xfrm>
-            <a:off x="5775259" y="45720"/>
-            <a:ext cx="534101" cy="502920"/>
+            <a:off x="7869601" y="3515868"/>
+            <a:ext cx="1182959" cy="1554480"/>
           </a:xfrm>
           <a:prstGeom prst="rect">
             <a:avLst/>
@@ -29571,54 +29043,6 @@
           </a:p>
         </p:txBody>
       </p:sp>
-      <p:pic>
-        <p:nvPicPr>
-          <p:cNvPr id="21" name="Image 0" descr="penguin">    </p:cNvPr>
-          <p:cNvPicPr>
-            <a:picLocks noChangeAspect="1"/>
-          </p:cNvPicPr>
-          <p:nvPr/>
-        </p:nvPicPr>
-        <p:blipFill>
-          <a:blip r:embed="rId1"/>
-          <a:stretch>
-            <a:fillRect/>
-          </a:stretch>
-        </p:blipFill>
-        <p:spPr>
-          <a:xfrm>
-            <a:off x="91440" y="3973068"/>
-            <a:ext cx="1109350" cy="1097280"/>
-          </a:xfrm>
-          <a:prstGeom prst="rect">
-            <a:avLst/>
-          </a:prstGeom>
-        </p:spPr>
-      </p:pic>
-      <p:pic>
-        <p:nvPicPr>
-          <p:cNvPr id="22" name="Image 1" descr="lady_beetle">    </p:cNvPr>
-          <p:cNvPicPr>
-            <a:picLocks noChangeAspect="1"/>
-          </p:cNvPicPr>
-          <p:nvPr/>
-        </p:nvPicPr>
-        <p:blipFill>
-          <a:blip r:embed="rId2"/>
-          <a:stretch>
-            <a:fillRect/>
-          </a:stretch>
-        </p:blipFill>
-        <p:spPr>
-          <a:xfrm>
-            <a:off x="1920240" y="45720"/>
-            <a:ext cx="780349" cy="777240"/>
-          </a:xfrm>
-          <a:prstGeom prst="rect">
-            <a:avLst/>
-          </a:prstGeom>
-        </p:spPr>
-      </p:pic>
     </p:spTree>
   </p:cSld>
   <p:clrMapOvr>
@@ -30643,7 +30067,7 @@
       </p:sp>
       <p:pic>
         <p:nvPicPr>
-          <p:cNvPr id="22" name="Image 0" descr="baby_chick">    </p:cNvPr>
+          <p:cNvPr id="22" name="Image 0" descr="kid">    </p:cNvPr>
           <p:cNvPicPr>
             <a:picLocks noChangeAspect="1"/>
           </p:cNvPicPr>
@@ -30656,9 +30080,9 @@
           </a:stretch>
         </p:blipFill>
         <p:spPr>
-          <a:xfrm flipH="1">
+          <a:xfrm>
             <a:off x="91440" y="3653028"/>
-            <a:ext cx="1526454" cy="1417320"/>
+            <a:ext cx="754014" cy="1417320"/>
           </a:xfrm>
           <a:prstGeom prst="rect">
             <a:avLst/>
@@ -30667,7 +30091,7 @@
       </p:pic>
       <p:pic>
         <p:nvPicPr>
-          <p:cNvPr id="23" name="Image 1" descr="chipmunk">    </p:cNvPr>
+          <p:cNvPr id="23" name="Image 1" descr="kid">    </p:cNvPr>
           <p:cNvPicPr>
             <a:picLocks noChangeAspect="1"/>
           </p:cNvPicPr>
@@ -30681,32 +30105,8 @@
         </p:blipFill>
         <p:spPr>
           <a:xfrm>
-            <a:off x="7440564" y="3515868"/>
-            <a:ext cx="1611996" cy="1554480"/>
-          </a:xfrm>
-          <a:prstGeom prst="rect">
-            <a:avLst/>
-          </a:prstGeom>
-        </p:spPr>
-      </p:pic>
-      <p:pic>
-        <p:nvPicPr>
-          <p:cNvPr id="24" name="Image 2" descr="bird">    </p:cNvPr>
-          <p:cNvPicPr>
-            <a:picLocks noChangeAspect="1"/>
-          </p:cNvPicPr>
-          <p:nvPr/>
-        </p:nvPicPr>
-        <p:blipFill>
-          <a:blip r:embed="rId3"/>
-          <a:stretch>
-            <a:fillRect/>
-          </a:stretch>
-        </p:blipFill>
-        <p:spPr>
-          <a:xfrm>
-            <a:off x="4835576" y="45720"/>
-            <a:ext cx="742264" cy="777240"/>
+            <a:off x="8104327" y="3515868"/>
+            <a:ext cx="948233" cy="1554480"/>
           </a:xfrm>
           <a:prstGeom prst="rect">
             <a:avLst/>
@@ -31825,7 +31225,7 @@
       </p:sp>
       <p:pic>
         <p:nvPicPr>
-          <p:cNvPr id="24" name="Image 0" descr="penguin">    </p:cNvPr>
+          <p:cNvPr id="24" name="Image 0" descr="animal">    </p:cNvPr>
           <p:cNvPicPr>
             <a:picLocks noChangeAspect="1"/>
           </p:cNvPicPr>
@@ -31840,7 +31240,7 @@
         <p:spPr>
           <a:xfrm>
             <a:off x="91440" y="3561588"/>
-            <a:ext cx="1525356" cy="1508760"/>
+            <a:ext cx="2312929" cy="1508760"/>
           </a:xfrm>
           <a:prstGeom prst="rect">
             <a:avLst/>
@@ -31849,7 +31249,7 @@
       </p:pic>
       <p:pic>
         <p:nvPicPr>
-          <p:cNvPr id="25" name="Image 1" descr="octopus">    </p:cNvPr>
+          <p:cNvPr id="25" name="Image 1" descr="sea">    </p:cNvPr>
           <p:cNvPicPr>
             <a:picLocks noChangeAspect="1"/>
           </p:cNvPicPr>
@@ -31863,32 +31263,8 @@
         </p:blipFill>
         <p:spPr>
           <a:xfrm>
-            <a:off x="7259604" y="3332988"/>
-            <a:ext cx="1792956" cy="1737360"/>
-          </a:xfrm>
-          <a:prstGeom prst="rect">
-            <a:avLst/>
-          </a:prstGeom>
-        </p:spPr>
-      </p:pic>
-      <p:pic>
-        <p:nvPicPr>
-          <p:cNvPr id="26" name="Image 2" descr="butterfly">    </p:cNvPr>
-          <p:cNvPicPr>
-            <a:picLocks noChangeAspect="1"/>
-          </p:cNvPicPr>
-          <p:nvPr/>
-        </p:nvPicPr>
-        <p:blipFill>
-          <a:blip r:embed="rId3"/>
-          <a:stretch>
-            <a:fillRect/>
-          </a:stretch>
-        </p:blipFill>
-        <p:spPr>
-          <a:xfrm>
-            <a:off x="1920240" y="45720"/>
-            <a:ext cx="777240" cy="777240"/>
+            <a:off x="6974677" y="3332988"/>
+            <a:ext cx="2077883" cy="1737360"/>
           </a:xfrm>
           <a:prstGeom prst="rect">
             <a:avLst/>

</xml_diff>

<commit_message>
Characters from the user's cleaner transparent grids
cut.py now cuts transparent grids: splits touching characters, drops crumbs. Each picture is drawn no taller than its resolution allows.

Co-Authored-By: Claude Opus 5.5 <noreply@anthropic.com>
Claude-Session: https://claude.ai/code/session_01XjTEwQ8YdBa1SjcPiYTm9z
</commit_message>
<xml_diff>
--- a/dammah-plus/01-alif.pptx
+++ b/dammah-plus/01-alif.pptx
@@ -3444,8 +3444,8 @@
         </p:blipFill>
         <p:spPr>
           <a:xfrm>
-            <a:off x="91440" y="2011680"/>
-            <a:ext cx="2832720" cy="1188720"/>
+            <a:off x="91440" y="1943100"/>
+            <a:ext cx="1115065" cy="1325880"/>
           </a:xfrm>
           <a:prstGeom prst="rect">
             <a:avLst/>
@@ -3468,8 +3468,8 @@
         </p:blipFill>
         <p:spPr>
           <a:xfrm>
-            <a:off x="7349033" y="1783080"/>
-            <a:ext cx="1703527" cy="1645920"/>
+            <a:off x="7726680" y="1943100"/>
+            <a:ext cx="1325880" cy="1325880"/>
           </a:xfrm>
           <a:prstGeom prst="rect">
             <a:avLst/>
@@ -5906,8 +5906,8 @@
         </p:blipFill>
         <p:spPr>
           <a:xfrm>
-            <a:off x="91440" y="3835908"/>
-            <a:ext cx="904845" cy="1234440"/>
+            <a:off x="91440" y="3881628"/>
+            <a:ext cx="929579" cy="1188720"/>
           </a:xfrm>
           <a:prstGeom prst="rect">
             <a:avLst/>
@@ -5930,8 +5930,8 @@
         </p:blipFill>
         <p:spPr>
           <a:xfrm>
-            <a:off x="8476305" y="4018788"/>
-            <a:ext cx="576255" cy="1051560"/>
+            <a:off x="8483072" y="3973068"/>
+            <a:ext cx="569488" cy="1097280"/>
           </a:xfrm>
           <a:prstGeom prst="rect">
             <a:avLst/>
@@ -7217,7 +7217,7 @@
         <p:spPr>
           <a:xfrm>
             <a:off x="91440" y="3561588"/>
-            <a:ext cx="858484" cy="1508760"/>
+            <a:ext cx="881116" cy="1508760"/>
           </a:xfrm>
           <a:prstGeom prst="rect">
             <a:avLst/>
@@ -7240,8 +7240,8 @@
         </p:blipFill>
         <p:spPr>
           <a:xfrm>
-            <a:off x="7662672" y="3332988"/>
-            <a:ext cx="1389888" cy="1737360"/>
+            <a:off x="7872527" y="3744468"/>
+            <a:ext cx="1180033" cy="1325880"/>
           </a:xfrm>
           <a:prstGeom prst="rect">
             <a:avLst/>
@@ -8551,8 +8551,32 @@
         </p:blipFill>
         <p:spPr>
           <a:xfrm>
-            <a:off x="91440" y="4064508"/>
-            <a:ext cx="1083290" cy="1005840"/>
+            <a:off x="91440" y="4018788"/>
+            <a:ext cx="1108344" cy="1051560"/>
+          </a:xfrm>
+          <a:prstGeom prst="rect">
+            <a:avLst/>
+          </a:prstGeom>
+        </p:spPr>
+      </p:pic>
+      <p:pic>
+        <p:nvPicPr>
+          <p:cNvPr id="26" name="Image 1" descr="animal">    </p:cNvPr>
+          <p:cNvPicPr>
+            <a:picLocks noChangeAspect="1"/>
+          </p:cNvPicPr>
+          <p:nvPr/>
+        </p:nvPicPr>
+        <p:blipFill>
+          <a:blip r:embed="rId2"/>
+          <a:stretch>
+            <a:fillRect/>
+          </a:stretch>
+        </p:blipFill>
+        <p:spPr>
+          <a:xfrm>
+            <a:off x="8335396" y="4018788"/>
+            <a:ext cx="717164" cy="1051560"/>
           </a:xfrm>
           <a:prstGeom prst="rect">
             <a:avLst/>
@@ -9888,7 +9912,7 @@
         <p:spPr>
           <a:xfrm>
             <a:off x="91440" y="3561588"/>
-            <a:ext cx="843397" cy="1508760"/>
+            <a:ext cx="872063" cy="1508760"/>
           </a:xfrm>
           <a:prstGeom prst="rect">
             <a:avLst/>
@@ -9911,8 +9935,8 @@
         </p:blipFill>
         <p:spPr>
           <a:xfrm>
-            <a:off x="8057053" y="3332988"/>
-            <a:ext cx="995507" cy="1737360"/>
+            <a:off x="8060527" y="3332988"/>
+            <a:ext cx="992033" cy="1737360"/>
           </a:xfrm>
           <a:prstGeom prst="rect">
             <a:avLst/>
@@ -11207,8 +11231,8 @@
         </p:blipFill>
         <p:spPr>
           <a:xfrm>
-            <a:off x="91440" y="3561588"/>
-            <a:ext cx="1409182" cy="1508760"/>
+            <a:off x="91440" y="4110228"/>
+            <a:ext cx="1648526" cy="960120"/>
           </a:xfrm>
           <a:prstGeom prst="rect">
             <a:avLst/>
@@ -11231,8 +11255,8 @@
         </p:blipFill>
         <p:spPr>
           <a:xfrm>
-            <a:off x="8150870" y="3332988"/>
-            <a:ext cx="901690" cy="1737360"/>
+            <a:off x="8094452" y="3881628"/>
+            <a:ext cx="958108" cy="1188720"/>
           </a:xfrm>
           <a:prstGeom prst="rect">
             <a:avLst/>
@@ -13674,7 +13698,7 @@
       </p:sp>
       <p:pic>
         <p:nvPicPr>
-          <p:cNvPr id="25" name="Image 0" descr="kid">    </p:cNvPr>
+          <p:cNvPr id="25" name="Image 0" descr="animal">    </p:cNvPr>
           <p:cNvPicPr>
             <a:picLocks noChangeAspect="1"/>
           </p:cNvPicPr>
@@ -13688,8 +13712,32 @@
         </p:blipFill>
         <p:spPr>
           <a:xfrm>
-            <a:off x="8473928" y="3790188"/>
-            <a:ext cx="578632" cy="1280160"/>
+            <a:off x="91440" y="3881628"/>
+            <a:ext cx="930768" cy="1188720"/>
+          </a:xfrm>
+          <a:prstGeom prst="rect">
+            <a:avLst/>
+          </a:prstGeom>
+        </p:spPr>
+      </p:pic>
+      <p:pic>
+        <p:nvPicPr>
+          <p:cNvPr id="26" name="Image 1" descr="kid">    </p:cNvPr>
+          <p:cNvPicPr>
+            <a:picLocks noChangeAspect="1"/>
+          </p:cNvPicPr>
+          <p:nvPr/>
+        </p:nvPicPr>
+        <p:blipFill>
+          <a:blip r:embed="rId2"/>
+          <a:stretch>
+            <a:fillRect/>
+          </a:stretch>
+        </p:blipFill>
+        <p:spPr>
+          <a:xfrm>
+            <a:off x="8476077" y="3835908"/>
+            <a:ext cx="576483" cy="1234440"/>
           </a:xfrm>
           <a:prstGeom prst="rect">
             <a:avLst/>
@@ -14685,7 +14733,7 @@
         <p:spPr>
           <a:xfrm>
             <a:off x="91440" y="3653028"/>
-            <a:ext cx="907085" cy="1417320"/>
+            <a:ext cx="888660" cy="1417320"/>
           </a:xfrm>
           <a:prstGeom prst="rect">
             <a:avLst/>
@@ -14708,8 +14756,8 @@
         </p:blipFill>
         <p:spPr>
           <a:xfrm>
-            <a:off x="7552487" y="3515868"/>
-            <a:ext cx="1500073" cy="1554480"/>
+            <a:off x="7869555" y="4018788"/>
+            <a:ext cx="1183005" cy="1051560"/>
           </a:xfrm>
           <a:prstGeom prst="rect">
             <a:avLst/>
@@ -15729,8 +15777,8 @@
         </p:blipFill>
         <p:spPr>
           <a:xfrm>
-            <a:off x="91440" y="3790188"/>
-            <a:ext cx="1112459" cy="1280160"/>
+            <a:off x="91440" y="4064508"/>
+            <a:ext cx="1078260" cy="1005840"/>
           </a:xfrm>
           <a:prstGeom prst="rect">
             <a:avLst/>
@@ -16776,7 +16824,7 @@
         <p:spPr>
           <a:xfrm>
             <a:off x="91440" y="3653028"/>
-            <a:ext cx="673227" cy="1417320"/>
+            <a:ext cx="613700" cy="1417320"/>
           </a:xfrm>
           <a:prstGeom prst="rect">
             <a:avLst/>
@@ -16799,8 +16847,8 @@
         </p:blipFill>
         <p:spPr>
           <a:xfrm>
-            <a:off x="8161843" y="3515868"/>
-            <a:ext cx="890717" cy="1554480"/>
+            <a:off x="8135417" y="3515868"/>
+            <a:ext cx="917143" cy="1554480"/>
           </a:xfrm>
           <a:prstGeom prst="rect">
             <a:avLst/>
@@ -17846,7 +17894,7 @@
         <p:spPr>
           <a:xfrm>
             <a:off x="91440" y="3653028"/>
-            <a:ext cx="643463" cy="1417320"/>
+            <a:ext cx="653385" cy="1417320"/>
           </a:xfrm>
           <a:prstGeom prst="rect">
             <a:avLst/>
@@ -17869,8 +17917,8 @@
         </p:blipFill>
         <p:spPr>
           <a:xfrm>
-            <a:off x="7913126" y="3515868"/>
-            <a:ext cx="1139434" cy="1554480"/>
+            <a:off x="7944216" y="3653028"/>
+            <a:ext cx="1108344" cy="1417320"/>
           </a:xfrm>
           <a:prstGeom prst="rect">
             <a:avLst/>
@@ -18876,7 +18924,7 @@
         <p:spPr>
           <a:xfrm>
             <a:off x="91440" y="3653028"/>
-            <a:ext cx="1279840" cy="1417320"/>
+            <a:ext cx="1292596" cy="1417320"/>
           </a:xfrm>
           <a:prstGeom prst="rect">
             <a:avLst/>
@@ -18899,8 +18947,8 @@
         </p:blipFill>
         <p:spPr>
           <a:xfrm>
-            <a:off x="6736385" y="3515868"/>
-            <a:ext cx="2316175" cy="1554480"/>
+            <a:off x="7446234" y="4064508"/>
+            <a:ext cx="1606326" cy="1005840"/>
           </a:xfrm>
           <a:prstGeom prst="rect">
             <a:avLst/>
@@ -21095,8 +21143,8 @@
         </p:blipFill>
         <p:spPr>
           <a:xfrm>
-            <a:off x="91440" y="1783080"/>
-            <a:ext cx="1711757" cy="1645920"/>
+            <a:off x="91440" y="1874520"/>
+            <a:ext cx="997793" cy="1463040"/>
           </a:xfrm>
           <a:prstGeom prst="rect">
             <a:avLst/>
@@ -21119,8 +21167,8 @@
         </p:blipFill>
         <p:spPr>
           <a:xfrm>
-            <a:off x="8176931" y="1783080"/>
-            <a:ext cx="875629" cy="1645920"/>
+            <a:off x="8221370" y="1783080"/>
+            <a:ext cx="831190" cy="1645920"/>
           </a:xfrm>
           <a:prstGeom prst="rect">
             <a:avLst/>
@@ -21944,8 +21992,8 @@
         </p:blipFill>
         <p:spPr>
           <a:xfrm>
-            <a:off x="91440" y="3241548"/>
-            <a:ext cx="830275" cy="1828800"/>
+            <a:off x="91440" y="3378708"/>
+            <a:ext cx="779846" cy="1691640"/>
           </a:xfrm>
           <a:prstGeom prst="rect">
             <a:avLst/>
@@ -21968,8 +22016,8 @@
         </p:blipFill>
         <p:spPr>
           <a:xfrm>
-            <a:off x="7706563" y="3241548"/>
-            <a:ext cx="1345997" cy="1828800"/>
+            <a:off x="7802072" y="1988820"/>
+            <a:ext cx="1250488" cy="1234440"/>
           </a:xfrm>
           <a:prstGeom prst="rect">
             <a:avLst/>
@@ -22818,8 +22866,8 @@
         </p:blipFill>
         <p:spPr>
           <a:xfrm>
-            <a:off x="91440" y="1783080"/>
-            <a:ext cx="1601480" cy="1645920"/>
+            <a:off x="91440" y="2057400"/>
+            <a:ext cx="1329903" cy="1097280"/>
           </a:xfrm>
           <a:prstGeom prst="rect">
             <a:avLst/>
@@ -22828,7 +22876,7 @@
       </p:pic>
       <p:pic>
         <p:nvPicPr>
-          <p:cNvPr id="19" name="Image 1" descr="bird">    </p:cNvPr>
+          <p:cNvPr id="19" name="Image 1" descr="animal">    </p:cNvPr>
           <p:cNvPicPr>
             <a:picLocks noChangeAspect="1"/>
           </p:cNvPicPr>
@@ -22842,8 +22890,8 @@
         </p:blipFill>
         <p:spPr>
           <a:xfrm>
-            <a:off x="7584399" y="1783080"/>
-            <a:ext cx="1468161" cy="1645920"/>
+            <a:off x="7434209" y="1988820"/>
+            <a:ext cx="1618351" cy="1234440"/>
           </a:xfrm>
           <a:prstGeom prst="rect">
             <a:avLst/>
@@ -23717,8 +23765,8 @@
         </p:blipFill>
         <p:spPr>
           <a:xfrm>
-            <a:off x="91440" y="3241548"/>
-            <a:ext cx="780898" cy="1828800"/>
+            <a:off x="91440" y="1783080"/>
+            <a:ext cx="701162" cy="1645920"/>
           </a:xfrm>
           <a:prstGeom prst="rect">
             <a:avLst/>
@@ -23741,8 +23789,8 @@
         </p:blipFill>
         <p:spPr>
           <a:xfrm>
-            <a:off x="7993685" y="3241548"/>
-            <a:ext cx="1058875" cy="1828800"/>
+            <a:off x="7992770" y="3332988"/>
+            <a:ext cx="1059790" cy="1737360"/>
           </a:xfrm>
           <a:prstGeom prst="rect">
             <a:avLst/>
@@ -24675,8 +24723,8 @@
         </p:blipFill>
         <p:spPr>
           <a:xfrm>
-            <a:off x="91440" y="3653028"/>
-            <a:ext cx="1564721" cy="1417320"/>
+            <a:off x="91440" y="3698748"/>
+            <a:ext cx="958748" cy="1371600"/>
           </a:xfrm>
           <a:prstGeom prst="rect">
             <a:avLst/>
@@ -24699,8 +24747,8 @@
         </p:blipFill>
         <p:spPr>
           <a:xfrm>
-            <a:off x="6736385" y="3515868"/>
-            <a:ext cx="2316175" cy="1554480"/>
+            <a:off x="7540417" y="4018788"/>
+            <a:ext cx="1512143" cy="1051560"/>
           </a:xfrm>
           <a:prstGeom prst="rect">
             <a:avLst/>
@@ -25895,8 +25943,8 @@
         </p:blipFill>
         <p:spPr>
           <a:xfrm>
-            <a:off x="91440" y="2103120"/>
-            <a:ext cx="510967" cy="1005840"/>
+            <a:off x="91440" y="2057400"/>
+            <a:ext cx="512430" cy="1097280"/>
           </a:xfrm>
           <a:prstGeom prst="rect">
             <a:avLst/>
@@ -27018,8 +27066,8 @@
         </p:blipFill>
         <p:spPr>
           <a:xfrm>
-            <a:off x="8470087" y="3790188"/>
-            <a:ext cx="582473" cy="1280160"/>
+            <a:off x="8471139" y="3835908"/>
+            <a:ext cx="581421" cy="1234440"/>
           </a:xfrm>
           <a:prstGeom prst="rect">
             <a:avLst/>
@@ -28015,7 +28063,7 @@
         <p:spPr>
           <a:xfrm>
             <a:off x="91440" y="3653028"/>
-            <a:ext cx="629290" cy="1417320"/>
+            <a:ext cx="602361" cy="1417320"/>
           </a:xfrm>
           <a:prstGeom prst="rect">
             <a:avLst/>
@@ -28038,8 +28086,8 @@
         </p:blipFill>
         <p:spPr>
           <a:xfrm>
-            <a:off x="7869601" y="3515868"/>
-            <a:ext cx="1182959" cy="1554480"/>
+            <a:off x="7391461" y="3653028"/>
+            <a:ext cx="1661099" cy="1417320"/>
           </a:xfrm>
           <a:prstGeom prst="rect">
             <a:avLst/>
@@ -29043,6 +29091,30 @@
           </a:p>
         </p:txBody>
       </p:sp>
+      <p:pic>
+        <p:nvPicPr>
+          <p:cNvPr id="21" name="Image 0" descr="animal">    </p:cNvPr>
+          <p:cNvPicPr>
+            <a:picLocks noChangeAspect="1"/>
+          </p:cNvPicPr>
+          <p:nvPr/>
+        </p:nvPicPr>
+        <p:blipFill>
+          <a:blip r:embed="rId1"/>
+          <a:stretch>
+            <a:fillRect/>
+          </a:stretch>
+        </p:blipFill>
+        <p:spPr>
+          <a:xfrm>
+            <a:off x="91440" y="3973068"/>
+            <a:ext cx="948050" cy="1097280"/>
+          </a:xfrm>
+          <a:prstGeom prst="rect">
+            <a:avLst/>
+          </a:prstGeom>
+        </p:spPr>
+      </p:pic>
     </p:spTree>
   </p:cSld>
   <p:clrMapOvr>
@@ -30082,7 +30154,7 @@
         <p:spPr>
           <a:xfrm>
             <a:off x="91440" y="3653028"/>
-            <a:ext cx="754014" cy="1417320"/>
+            <a:ext cx="715747" cy="1417320"/>
           </a:xfrm>
           <a:prstGeom prst="rect">
             <a:avLst/>
@@ -30105,8 +30177,8 @@
         </p:blipFill>
         <p:spPr>
           <a:xfrm>
-            <a:off x="8104327" y="3515868"/>
-            <a:ext cx="948233" cy="1554480"/>
+            <a:off x="8062356" y="3515868"/>
+            <a:ext cx="990204" cy="1554480"/>
           </a:xfrm>
           <a:prstGeom prst="rect">
             <a:avLst/>
@@ -31239,8 +31311,8 @@
         </p:blipFill>
         <p:spPr>
           <a:xfrm>
-            <a:off x="91440" y="3561588"/>
-            <a:ext cx="2312929" cy="1508760"/>
+            <a:off x="91440" y="3744468"/>
+            <a:ext cx="1723644" cy="1325880"/>
           </a:xfrm>
           <a:prstGeom prst="rect">
             <a:avLst/>
@@ -31263,8 +31335,8 @@
         </p:blipFill>
         <p:spPr>
           <a:xfrm>
-            <a:off x="6974677" y="3332988"/>
-            <a:ext cx="2077883" cy="1737360"/>
+            <a:off x="7330516" y="3835908"/>
+            <a:ext cx="1722044" cy="1234440"/>
           </a:xfrm>
           <a:prstGeom prst="rect">
             <a:avLst/>

</xml_diff>